<commit_message>
feat(story): dedicated evaluation-vs-observations slide per case study
The observation validation was buried as bullets on the interpretation slide
and the validation.png figure was never placed; the older Naches run had no
validation at all. Now: validate_run.py was run on that case, and each study
with a validation.json gets its own evaluation slide — obs inventory (SNOTEL /
gages / wells), per-target verdict (compared vs context-only + what blocks
rigorous validation), and the validation figure. 22 slides, 4 studies.

Co-Authored-By: Claude Opus 4.8 <noreply@anthropic.com>
</commit_message>
<xml_diff>
--- a/docs/slides/story_20260702.pptx
+++ b/docs/slides/story_20260702.pptx
@@ -24,6 +24,9 @@
     <p:sldId id="272" r:id="rId23"/>
     <p:sldId id="273" r:id="rId24"/>
     <p:sldId id="274" r:id="rId25"/>
+    <p:sldId id="275" r:id="rId26"/>
+    <p:sldId id="276" r:id="rId27"/>
+    <p:sldId id="277" r:id="rId28"/>
   </p:sldIdLst>
   <p:sldSz cx="12191695" cy="6858000" type="screen4x3"/>
   <p:notesSz cx="6858000" cy="9144000"/>
@@ -3263,195 +3266,35 @@
                   <a:srgbClr val="0F172A"/>
                 </a:solidFill>
               </a:rPr>
-              <a:t>Naches — analyzer interpretation</a:t>
-            </a:r>
-          </a:p>
-        </p:txBody>
-      </p:sp>
-      <p:sp>
-        <p:nvSpPr>
-          <p:cNvPr id="3" name="TextBox 2"/>
-          <p:cNvSpPr txBox="1"/>
+              <a:t>Naches — results (continued)</a:t>
+            </a:r>
+          </a:p>
+        </p:txBody>
+      </p:sp>
+      <p:pic>
+        <p:nvPicPr>
+          <p:cNvPr id="3" name="Picture 2" descr="debug_timeseries.png"/>
+          <p:cNvPicPr>
+            <a:picLocks noChangeAspect="1"/>
+          </p:cNvPicPr>
           <p:nvPr/>
-        </p:nvSpPr>
-        <p:spPr>
-          <a:xfrm>
-            <a:off x="457200" y="1188720"/>
-            <a:ext cx="11277295" cy="5303520"/>
+        </p:nvPicPr>
+        <p:blipFill>
+          <a:blip r:embed="rId2"/>
+          <a:stretch>
+            <a:fillRect/>
+          </a:stretch>
+        </p:blipFill>
+        <p:spPr>
+          <a:xfrm>
+            <a:off x="472287" y="1188720"/>
+            <a:ext cx="11247120" cy="4183902"/>
           </a:xfrm>
           <a:prstGeom prst="rect">
             <a:avLst/>
           </a:prstGeom>
-          <a:noFill/>
-        </p:spPr>
-        <p:txBody>
-          <a:bodyPr wrap="square">
-            <a:spAutoFit/>
-          </a:bodyPr>
-          <a:lstStyle/>
-          <a:p>
-            <a:pPr>
-              <a:spcAft>
-                <a:spcPts val="600"/>
-              </a:spcAft>
-            </a:pPr>
-            <a:r>
-              <a:rPr b="1" sz="1400">
-                <a:solidFill>
-                  <a:srgbClr val="2C7FB8"/>
-                </a:solidFill>
-              </a:rPr>
-              <a:t>finding:  </a:t>
-            </a:r>
-            <a:r>
-              <a:rPr sz="1400">
-                <a:solidFill>
-                  <a:srgbClr val="0F172A"/>
-                </a:solidFill>
-              </a:rPr>
-              <a:t>precip is quantized to 2 value(s) [793, 1373] mm/yr — coarse DATM forcing, NOT elevation-resolved</a:t>
-            </a:r>
-          </a:p>
-          <a:p>
-            <a:pPr>
-              <a:spcAft>
-                <a:spcPts val="600"/>
-              </a:spcAft>
-            </a:pPr>
-            <a:r>
-              <a:rPr b="1" sz="1400">
-                <a:solidFill>
-                  <a:srgbClr val="2C7FB8"/>
-                </a:solidFill>
-              </a:rPr>
-              <a:t>finding:  </a:t>
-            </a:r>
-            <a:r>
-              <a:rPr sz="1400">
-                <a:solidFill>
-                  <a:srgbClr val="0F172A"/>
-                </a:solidFill>
-              </a:rPr>
-              <a:t>recharge tracks precip (r=0.908) more than elevation (r=0.598) — response is forcing/soil-controlled</a:t>
-            </a:r>
-          </a:p>
-          <a:p>
-            <a:pPr>
-              <a:spcAft>
-                <a:spcPts val="600"/>
-              </a:spcAft>
-            </a:pPr>
-            <a:r>
-              <a:rPr b="1" sz="1400">
-                <a:solidFill>
-                  <a:srgbClr val="2C7FB8"/>
-                </a:solidFill>
-              </a:rPr>
-              <a:t>finding:  </a:t>
-            </a:r>
-            <a:r>
-              <a:rPr sz="1400">
-                <a:solidFill>
-                  <a:srgbClr val="0F172A"/>
-                </a:solidFill>
-              </a:rPr>
-              <a:t>linear elevation fit is weak (r2=0.358) — the elevation 'gradient' is not a reliable summary</a:t>
-            </a:r>
-          </a:p>
-          <a:p>
-            <a:pPr>
-              <a:spcAft>
-                <a:spcPts val="600"/>
-              </a:spcAft>
-            </a:pPr>
-            <a:r>
-              <a:rPr b="1" sz="1400">
-                <a:solidFill>
-                  <a:srgbClr val="2C7FB8"/>
-                </a:solidFill>
-              </a:rPr>
-              <a:t>finding:  </a:t>
-            </a:r>
-            <a:r>
-              <a:rPr sz="1400">
-                <a:solidFill>
-                  <a:srgbClr val="0F172A"/>
-                </a:solidFill>
-              </a:rPr>
-              <a:t>soil control (forcing held at 1373 mm/yr, 7 columns): strongest predictor = recharge_vs_clay_max (r=-0.906)</a:t>
-            </a:r>
-          </a:p>
-          <a:p>
-            <a:pPr>
-              <a:spcAft>
-                <a:spcPts val="600"/>
-              </a:spcAft>
-            </a:pPr>
-            <a:r>
-              <a:rPr b="1" sz="1400">
-                <a:solidFill>
-                  <a:srgbClr val="2C7FB8"/>
-                </a:solidFill>
-              </a:rPr>
-              <a:t>finding:  </a:t>
-            </a:r>
-            <a:r>
-              <a:rPr sz="1400">
-                <a:solidFill>
-                  <a:srgbClr val="0F172A"/>
-                </a:solidFill>
-              </a:rPr>
-              <a:t>[COMPARED] water-table depth: model ZWT mean 8.41 m vs Fan 29.02 m (bias -20.61 m)</a:t>
-            </a:r>
-          </a:p>
-          <a:p>
-            <a:pPr>
-              <a:spcAft>
-                <a:spcPts val="600"/>
-              </a:spcAft>
-            </a:pPr>
-            <a:r>
-              <a:rPr b="1" sz="1400">
-                <a:solidFill>
-                  <a:srgbClr val="2C7FB8"/>
-                </a:solidFill>
-              </a:rPr>
-              <a:t>finding:  </a:t>
-            </a:r>
-            <a:r>
-              <a:rPr sz="1400">
-                <a:solidFill>
-                  <a:srgbClr val="0F172A"/>
-                </a:solidFill>
-              </a:rPr>
-              <a:t>[context-only] integrated streamflow: modeled basin water yield (runoff+recharge) ≈ 557.8 mm/yr (reference; a single column produces no routed streamflow)</a:t>
-            </a:r>
-          </a:p>
-          <a:p>
-            <a:pPr>
-              <a:spcAft>
-                <a:spcPts val="600"/>
-              </a:spcAft>
-            </a:pPr>
-            <a:r>
-              <a:rPr b="1" sz="1400">
-                <a:solidFill>
-                  <a:srgbClr val="2C7FB8"/>
-                </a:solidFill>
-              </a:rPr>
-              <a:t>finding:  </a:t>
-            </a:r>
-            <a:r>
-              <a:rPr sz="1400">
-                <a:solidFill>
-                  <a:srgbClr val="0F172A"/>
-                </a:solidFill>
-              </a:rPr>
-              <a:t>[context-only] snow water equivalent: SNOTEL stations present, but the run has no SWE output to compare</a:t>
-            </a:r>
-          </a:p>
-        </p:txBody>
-      </p:sp>
+        </p:spPr>
+      </p:pic>
     </p:spTree>
   </p:cSld>
   <p:clrMapOvr>
@@ -3503,7 +3346,7 @@
                   <a:srgbClr val="0F172A"/>
                 </a:solidFill>
               </a:rPr>
-              <a:t>Case 3 — Walla Walla</a:t>
+              <a:t>Naches — analyzer interpretation</a:t>
             </a:r>
           </a:p>
         </p:txBody>
@@ -3516,8 +3359,8 @@
         </p:nvSpPr>
         <p:spPr>
           <a:xfrm>
-            <a:off x="457200" y="868680"/>
-            <a:ext cx="11277295" cy="365760"/>
+            <a:off x="457200" y="1188720"/>
+            <a:ext cx="11277295" cy="5303520"/>
           </a:xfrm>
           <a:prstGeom prst="rect">
             <a:avLst/>
@@ -3536,75 +3379,22 @@
               </a:spcAft>
             </a:pPr>
             <a:r>
-              <a:rPr sz="1300" b="0">
-                <a:solidFill>
-                  <a:srgbClr val="475569"/>
-                </a:solidFill>
-              </a:rPr>
-              <a:t>HUC 17070102 · 4600.97 km² · elevation 169.4–1675.0 m</a:t>
-            </a:r>
-          </a:p>
-        </p:txBody>
-      </p:sp>
-      <p:sp>
-        <p:nvSpPr>
-          <p:cNvPr id="4" name="TextBox 3"/>
-          <p:cNvSpPr txBox="1"/>
-          <p:nvPr/>
-        </p:nvSpPr>
-        <p:spPr>
-          <a:xfrm>
-            <a:off x="457200" y="1371600"/>
-            <a:ext cx="11277295" cy="1005840"/>
-          </a:xfrm>
-          <a:prstGeom prst="rect">
-            <a:avLst/>
-          </a:prstGeom>
-          <a:noFill/>
-        </p:spPr>
-        <p:txBody>
-          <a:bodyPr wrap="square">
-            <a:spAutoFit/>
-          </a:bodyPr>
-          <a:lstStyle/>
-          <a:p>
-            <a:pPr>
-              <a:spcAft>
-                <a:spcPts val="600"/>
-              </a:spcAft>
-            </a:pPr>
-            <a:r>
-              <a:rPr sz="1800" b="1">
+              <a:rPr b="1" sz="1400">
                 <a:solidFill>
                   <a:srgbClr val="2C7FB8"/>
                 </a:solidFill>
               </a:rPr>
-              <a:t>“Partitioning of runoff/recharge in the Walla Walla basin (HUC8 17070102), validate with observations. Thanks”</a:t>
-            </a:r>
-          </a:p>
-        </p:txBody>
-      </p:sp>
-      <p:sp>
-        <p:nvSpPr>
-          <p:cNvPr id="5" name="TextBox 4"/>
-          <p:cNvSpPr txBox="1"/>
-          <p:nvPr/>
-        </p:nvSpPr>
-        <p:spPr>
-          <a:xfrm>
-            <a:off x="457200" y="2468880"/>
-            <a:ext cx="11277295" cy="3931920"/>
-          </a:xfrm>
-          <a:prstGeom prst="rect">
-            <a:avLst/>
-          </a:prstGeom>
-          <a:noFill/>
-        </p:spPr>
-        <p:txBody>
-          <a:bodyPr wrap="square">
-            <a:spAutoFit/>
-          </a:bodyPr>
-          <a:lstStyle/>
+              <a:t>finding:  </a:t>
+            </a:r>
+            <a:r>
+              <a:rPr sz="1400">
+                <a:solidFill>
+                  <a:srgbClr val="0F172A"/>
+                </a:solidFill>
+              </a:rPr>
+              <a:t>precip is quantized to 2 value(s) [793, 1373] mm/yr — coarse DATM forcing, NOT elevation-resolved</a:t>
+            </a:r>
+          </a:p>
           <a:p>
             <a:pPr>
               <a:spcAft>
@@ -3617,7 +3407,7 @@
                   <a:srgbClr val="2C7FB8"/>
                 </a:solidFill>
               </a:rPr>
-              <a:t>goal:  </a:t>
+              <a:t>finding:  </a:t>
             </a:r>
             <a:r>
               <a:rPr sz="1400">
@@ -3625,7 +3415,7 @@
                   <a:srgbClr val="0F172A"/>
                 </a:solidFill>
               </a:rPr>
-              <a:t>Mechanistic: quantify column-scale partitioning of precipitation among surface runoff, sub-surface drainage/deep recharge (QDRAI), and ET, and its sensitivity to the levers the stack can pull (soil texture, forcing period)</a:t>
+              <a:t>recharge tracks precip (r=0.908) more than elevation (r=0.598) — response is forcing/soil-controlled</a:t>
             </a:r>
           </a:p>
           <a:p>
@@ -3640,7 +3430,7 @@
                   <a:srgbClr val="2C7FB8"/>
                 </a:solidFill>
               </a:rPr>
-              <a:t>goal:  </a:t>
+              <a:t>finding:  </a:t>
             </a:r>
             <a:r>
               <a:rPr sz="1400">
@@ -3648,7 +3438,7 @@
                   <a:srgbClr val="0F172A"/>
                 </a:solidFill>
               </a:rPr>
-              <a:t>Validation: compare simulated water balance against observed streamflow (integrated), water-table depth, and SNOTEL SWE — to the extent each is feasible in-domain</a:t>
+              <a:t>linear elevation fit is weak (r2=0.358) — the elevation 'gradient' is not a reliable summary</a:t>
             </a:r>
           </a:p>
           <a:p>
@@ -3663,7 +3453,7 @@
                   <a:srgbClr val="2C7FB8"/>
                 </a:solidFill>
               </a:rPr>
-              <a:t>sampling:  </a:t>
+              <a:t>finding:  </a:t>
             </a:r>
             <a:r>
               <a:rPr sz="1400">
@@ -3671,99 +3461,7 @@
                   <a:srgbClr val="0F172A"/>
                 </a:solidFill>
               </a:rPr>
-              <a:t>N=8 — stratified (soil × elevation-band surface data) with forcing-period treatments</a:t>
-            </a:r>
-          </a:p>
-          <a:p>
-            <a:pPr>
-              <a:spcAft>
-                <a:spcPts val="600"/>
-              </a:spcAft>
-            </a:pPr>
-            <a:r>
-              <a:rPr b="1" sz="1400">
-                <a:solidFill>
-                  <a:srgbClr val="2C7FB8"/>
-                </a:solidFill>
-              </a:rPr>
-              <a:t>why N:  </a:t>
-            </a:r>
-            <a:r>
-              <a:rPr sz="1400">
-                <a:solidFill>
-                  <a:srgbClr val="0F172A"/>
-                </a:solidFill>
-              </a:rPr>
-              <a:t>Four elevation bands give surface-data (soil/PFT) spanning across the basin; sampling ~2 columns per band (dominant + secondary soil where heterogeneity exists once gridded soil is ingested) yields 8. This is NOT an elevation/climate test — forcing is uniform — it spans surface heterogeneity. The forcing-period axis (baseline/wet/drought) is applied as a treatment over the same columns, not as extra columns, to probe partitioning sensitivity to climate variability.</a:t>
-            </a:r>
-          </a:p>
-          <a:p>
-            <a:pPr>
-              <a:spcAft>
-                <a:spcPts val="600"/>
-              </a:spcAft>
-            </a:pPr>
-            <a:r>
-              <a:rPr b="1" sz="1400">
-                <a:solidFill>
-                  <a:srgbClr val="2C7FB8"/>
-                </a:solidFill>
-              </a:rPr>
-              <a:t>feasibility:  </a:t>
-            </a:r>
-            <a:r>
-              <a:rPr sz="1400">
-                <a:solidFill>
-                  <a:srgbClr val="0F172A"/>
-                </a:solidFill>
-              </a:rPr>
-              <a:t>partial</a:t>
-            </a:r>
-          </a:p>
-          <a:p>
-            <a:pPr>
-              <a:spcAft>
-                <a:spcPts val="600"/>
-              </a:spcAft>
-            </a:pPr>
-            <a:r>
-              <a:rPr b="1" sz="1400">
-                <a:solidFill>
-                  <a:srgbClr val="2C7FB8"/>
-                </a:solidFill>
-              </a:rPr>
-              <a:t>not answerable:  </a:t>
-            </a:r>
-            <a:r>
-              <a:rPr sz="1400">
-                <a:solidFill>
-                  <a:srgbClr val="0F172A"/>
-                </a:solidFill>
-              </a:rPr>
-              <a:t>Elevation/climate-gradient control on partitioning (snow-dominated headwaters vs. semi-arid lowland) — needs elevation-downscaled forcing</a:t>
-            </a:r>
-          </a:p>
-          <a:p>
-            <a:pPr>
-              <a:spcAft>
-                <a:spcPts val="600"/>
-              </a:spcAft>
-            </a:pPr>
-            <a:r>
-              <a:rPr b="1" sz="1400">
-                <a:solidFill>
-                  <a:srgbClr val="2C7FB8"/>
-                </a:solidFill>
-              </a:rPr>
-              <a:t>not answerable:  </a:t>
-            </a:r>
-            <a:r>
-              <a:rPr sz="1400">
-                <a:solidFill>
-                  <a:srgbClr val="0F172A"/>
-                </a:solidFill>
-              </a:rPr>
-              <a:t>SNOTEL SWE / montane snowpack validation — needs elevation-downscaled forcing + snow/SWE history output</a:t>
+              <a:t>soil control (forcing held at 1373 mm/yr, 7 columns): strongest predictor = recharge_vs_clay_max (r=-0.906)</a:t>
             </a:r>
           </a:p>
         </p:txBody>
@@ -3819,14 +3517,167 @@
                   <a:srgbClr val="0F172A"/>
                 </a:solidFill>
               </a:rPr>
-              <a:t>Walla Walla — sampling design (Tier-2 expander)</a:t>
+              <a:t>Naches — evaluation vs observations</a:t>
+            </a:r>
+          </a:p>
+        </p:txBody>
+      </p:sp>
+      <p:sp>
+        <p:nvSpPr>
+          <p:cNvPr id="3" name="TextBox 2"/>
+          <p:cNvSpPr txBox="1"/>
+          <p:nvPr/>
+        </p:nvSpPr>
+        <p:spPr>
+          <a:xfrm>
+            <a:off x="457200" y="868680"/>
+            <a:ext cx="11277295" cy="365760"/>
+          </a:xfrm>
+          <a:prstGeom prst="rect">
+            <a:avLst/>
+          </a:prstGeom>
+          <a:noFill/>
+        </p:spPr>
+        <p:txBody>
+          <a:bodyPr wrap="square">
+            <a:spAutoFit/>
+          </a:bodyPr>
+          <a:lstStyle/>
+          <a:p>
+            <a:pPr>
+              <a:spcAft>
+                <a:spcPts val="600"/>
+              </a:spcAft>
+            </a:pPr>
+            <a:r>
+              <a:rPr sz="1300" b="0">
+                <a:solidFill>
+                  <a:srgbClr val="475569"/>
+                </a:solidFill>
+              </a:rPr>
+              <a:t>what could be compared honestly, and what still blocks rigorous validation</a:t>
+            </a:r>
+          </a:p>
+        </p:txBody>
+      </p:sp>
+      <p:sp>
+        <p:nvSpPr>
+          <p:cNvPr id="4" name="TextBox 3"/>
+          <p:cNvSpPr txBox="1"/>
+          <p:nvPr/>
+        </p:nvSpPr>
+        <p:spPr>
+          <a:xfrm>
+            <a:off x="457200" y="1143000"/>
+            <a:ext cx="11277295" cy="2194560"/>
+          </a:xfrm>
+          <a:prstGeom prst="rect">
+            <a:avLst/>
+          </a:prstGeom>
+          <a:noFill/>
+        </p:spPr>
+        <p:txBody>
+          <a:bodyPr wrap="square">
+            <a:spAutoFit/>
+          </a:bodyPr>
+          <a:lstStyle/>
+          <a:p>
+            <a:pPr>
+              <a:spcAft>
+                <a:spcPts val="600"/>
+              </a:spcAft>
+            </a:pPr>
+            <a:r>
+              <a:rPr b="1" sz="1300">
+                <a:solidFill>
+                  <a:srgbClr val="2C7FB8"/>
+                </a:solidFill>
+              </a:rPr>
+              <a:t>in-domain obs:  </a:t>
+            </a:r>
+            <a:r>
+              <a:rPr sz="1300">
+                <a:solidFill>
+                  <a:srgbClr val="0F172A"/>
+                </a:solidFill>
+              </a:rPr>
+              <a:t>SNOTEL 6 · stream gages 93 · GW wells 200 (5/6 sampled have records)</a:t>
+            </a:r>
+          </a:p>
+          <a:p>
+            <a:pPr>
+              <a:spcAft>
+                <a:spcPts val="600"/>
+              </a:spcAft>
+            </a:pPr>
+            <a:r>
+              <a:rPr b="1" sz="1300">
+                <a:solidFill>
+                  <a:srgbClr val="2C7FB8"/>
+                </a:solidFill>
+              </a:rPr>
+              <a:t>✓ COMPARED — water-table depth:  </a:t>
+            </a:r>
+            <a:r>
+              <a:rPr sz="1300">
+                <a:solidFill>
+                  <a:srgbClr val="0F172A"/>
+                </a:solidFill>
+              </a:rPr>
+              <a:t>model ZWT mean 8.41 m vs Fan 29.02 m (bias -20.61 m)</a:t>
+            </a:r>
+          </a:p>
+          <a:p>
+            <a:pPr>
+              <a:spcAft>
+                <a:spcPts val="600"/>
+              </a:spcAft>
+            </a:pPr>
+            <a:r>
+              <a:rPr b="1" sz="1300">
+                <a:solidFill>
+                  <a:srgbClr val="2C7FB8"/>
+                </a:solidFill>
+              </a:rPr>
+              <a:t>· context-only — integrated streamflow:  </a:t>
+            </a:r>
+            <a:r>
+              <a:rPr sz="1300">
+                <a:solidFill>
+                  <a:srgbClr val="0F172A"/>
+                </a:solidFill>
+              </a:rPr>
+              <a:t>modeled basin water yield (runoff+recharge) ≈ 557.8 mm/yr (reference; a single column produces no routed streamflow)  — needs: runoff routing / column aggregation</a:t>
+            </a:r>
+          </a:p>
+          <a:p>
+            <a:pPr>
+              <a:spcAft>
+                <a:spcPts val="600"/>
+              </a:spcAft>
+            </a:pPr>
+            <a:r>
+              <a:rPr b="1" sz="1300">
+                <a:solidFill>
+                  <a:srgbClr val="2C7FB8"/>
+                </a:solidFill>
+              </a:rPr>
+              <a:t>· context-only — snow water equivalent:  </a:t>
+            </a:r>
+            <a:r>
+              <a:rPr sz="1300">
+                <a:solidFill>
+                  <a:srgbClr val="0F172A"/>
+                </a:solidFill>
+              </a:rPr>
+              <a:t>SNOTEL stations present, but the run has no SWE output to compare  — needs: snow/SWE history output + elevation-downscaled forcing</a:t>
             </a:r>
           </a:p>
         </p:txBody>
       </p:sp>
       <p:pic>
         <p:nvPicPr>
-          <p:cNvPr id="3" name="Picture 2" descr="sampling_design.png"/>
+          <p:cNvPr id="5" name="Picture 4" descr="validation.png"/>
           <p:cNvPicPr>
             <a:picLocks noChangeAspect="1"/>
           </p:cNvPicPr>
@@ -3840,8 +3691,8 @@
         </p:blipFill>
         <p:spPr>
           <a:xfrm>
-            <a:off x="2067408" y="1051560"/>
-            <a:ext cx="8056879" cy="5577840"/>
+            <a:off x="2235985" y="3520440"/>
+            <a:ext cx="7719724" cy="3200400"/>
           </a:xfrm>
           <a:prstGeom prst="rect">
             <a:avLst/>
@@ -3899,7 +3750,7 @@
                   <a:srgbClr val="0F172A"/>
                 </a:solidFill>
               </a:rPr>
-              <a:t>Walla Walla — execution &amp; results</a:t>
+              <a:t>Case 3 — Walla Walla</a:t>
             </a:r>
           </a:p>
         </p:txBody>
@@ -3912,8 +3763,8 @@
         </p:nvSpPr>
         <p:spPr>
           <a:xfrm>
-            <a:off x="457200" y="1005840"/>
-            <a:ext cx="11277295" cy="457200"/>
+            <a:off x="457200" y="868680"/>
+            <a:ext cx="11277295" cy="365760"/>
           </a:xfrm>
           <a:prstGeom prst="rect">
             <a:avLst/>
@@ -3932,72 +3783,238 @@
               </a:spcAft>
             </a:pPr>
             <a:r>
-              <a:rPr b="1" sz="1400">
-                <a:solidFill>
-                  <a:srgbClr val="2C7FB8"/>
-                </a:solidFill>
-              </a:rPr>
-              <a:t>execution:  </a:t>
-            </a:r>
-            <a:r>
-              <a:rPr sz="1400">
-                <a:solidFill>
-                  <a:srgbClr val="0F172A"/>
-                </a:solidFill>
-              </a:rPr>
-              <a:t>4/4 columns succeeded · ~7 min each (~15 s clone per column, shared executable)</a:t>
-            </a:r>
-          </a:p>
-        </p:txBody>
-      </p:sp>
-      <p:pic>
-        <p:nvPicPr>
-          <p:cNvPr id="4" name="Picture 3" descr="elevation_gradient.png"/>
-          <p:cNvPicPr>
-            <a:picLocks noChangeAspect="1"/>
-          </p:cNvPicPr>
+              <a:rPr sz="1300" b="0">
+                <a:solidFill>
+                  <a:srgbClr val="475569"/>
+                </a:solidFill>
+              </a:rPr>
+              <a:t>HUC 17070102 · 4600.97 km² · elevation 169.4–1675.0 m</a:t>
+            </a:r>
+          </a:p>
+        </p:txBody>
+      </p:sp>
+      <p:sp>
+        <p:nvSpPr>
+          <p:cNvPr id="4" name="TextBox 3"/>
+          <p:cNvSpPr txBox="1"/>
           <p:nvPr/>
-        </p:nvPicPr>
-        <p:blipFill>
-          <a:blip r:embed="rId2"/>
-          <a:stretch>
-            <a:fillRect/>
-          </a:stretch>
-        </p:blipFill>
-        <p:spPr>
-          <a:xfrm>
-            <a:off x="2181260" y="1600200"/>
-            <a:ext cx="7829174" cy="2514600"/>
+        </p:nvSpPr>
+        <p:spPr>
+          <a:xfrm>
+            <a:off x="457200" y="1371600"/>
+            <a:ext cx="11277295" cy="1005840"/>
           </a:xfrm>
           <a:prstGeom prst="rect">
             <a:avLst/>
           </a:prstGeom>
-        </p:spPr>
-      </p:pic>
-      <p:pic>
-        <p:nvPicPr>
-          <p:cNvPr id="5" name="Picture 4" descr="soil_control.png"/>
-          <p:cNvPicPr>
-            <a:picLocks noChangeAspect="1"/>
-          </p:cNvPicPr>
+          <a:noFill/>
+        </p:spPr>
+        <p:txBody>
+          <a:bodyPr wrap="square">
+            <a:spAutoFit/>
+          </a:bodyPr>
+          <a:lstStyle/>
+          <a:p>
+            <a:pPr>
+              <a:spcAft>
+                <a:spcPts val="600"/>
+              </a:spcAft>
+            </a:pPr>
+            <a:r>
+              <a:rPr sz="1800" b="1">
+                <a:solidFill>
+                  <a:srgbClr val="2C7FB8"/>
+                </a:solidFill>
+              </a:rPr>
+              <a:t>“Partitioning of runoff/recharge in the Walla Walla basin (HUC8 17070102), validate with observations. Thanks”</a:t>
+            </a:r>
+          </a:p>
+        </p:txBody>
+      </p:sp>
+      <p:sp>
+        <p:nvSpPr>
+          <p:cNvPr id="5" name="TextBox 4"/>
+          <p:cNvSpPr txBox="1"/>
           <p:nvPr/>
-        </p:nvPicPr>
-        <p:blipFill>
-          <a:blip r:embed="rId3"/>
-          <a:stretch>
-            <a:fillRect/>
-          </a:stretch>
-        </p:blipFill>
-        <p:spPr>
-          <a:xfrm>
-            <a:off x="3390104" y="4251960"/>
-            <a:ext cx="5411487" cy="2514600"/>
+        </p:nvSpPr>
+        <p:spPr>
+          <a:xfrm>
+            <a:off x="457200" y="2468880"/>
+            <a:ext cx="11277295" cy="3931920"/>
           </a:xfrm>
           <a:prstGeom prst="rect">
             <a:avLst/>
           </a:prstGeom>
-        </p:spPr>
-      </p:pic>
+          <a:noFill/>
+        </p:spPr>
+        <p:txBody>
+          <a:bodyPr wrap="square">
+            <a:spAutoFit/>
+          </a:bodyPr>
+          <a:lstStyle/>
+          <a:p>
+            <a:pPr>
+              <a:spcAft>
+                <a:spcPts val="600"/>
+              </a:spcAft>
+            </a:pPr>
+            <a:r>
+              <a:rPr b="1" sz="1400">
+                <a:solidFill>
+                  <a:srgbClr val="2C7FB8"/>
+                </a:solidFill>
+              </a:rPr>
+              <a:t>goal:  </a:t>
+            </a:r>
+            <a:r>
+              <a:rPr sz="1400">
+                <a:solidFill>
+                  <a:srgbClr val="0F172A"/>
+                </a:solidFill>
+              </a:rPr>
+              <a:t>Mechanistic: quantify column-scale partitioning of precipitation among surface runoff, sub-surface drainage/deep recharge (QDRAI), and ET, and its sensitivity to the levers the stack can pull (soil texture, forcing period)</a:t>
+            </a:r>
+          </a:p>
+          <a:p>
+            <a:pPr>
+              <a:spcAft>
+                <a:spcPts val="600"/>
+              </a:spcAft>
+            </a:pPr>
+            <a:r>
+              <a:rPr b="1" sz="1400">
+                <a:solidFill>
+                  <a:srgbClr val="2C7FB8"/>
+                </a:solidFill>
+              </a:rPr>
+              <a:t>goal:  </a:t>
+            </a:r>
+            <a:r>
+              <a:rPr sz="1400">
+                <a:solidFill>
+                  <a:srgbClr val="0F172A"/>
+                </a:solidFill>
+              </a:rPr>
+              <a:t>Validation: compare simulated water balance against observed streamflow (integrated), water-table depth, and SNOTEL SWE — to the extent each is feasible in-domain</a:t>
+            </a:r>
+          </a:p>
+          <a:p>
+            <a:pPr>
+              <a:spcAft>
+                <a:spcPts val="600"/>
+              </a:spcAft>
+            </a:pPr>
+            <a:r>
+              <a:rPr b="1" sz="1400">
+                <a:solidFill>
+                  <a:srgbClr val="2C7FB8"/>
+                </a:solidFill>
+              </a:rPr>
+              <a:t>sampling:  </a:t>
+            </a:r>
+            <a:r>
+              <a:rPr sz="1400">
+                <a:solidFill>
+                  <a:srgbClr val="0F172A"/>
+                </a:solidFill>
+              </a:rPr>
+              <a:t>N=8 — stratified (soil × elevation-band surface data) with forcing-period treatments</a:t>
+            </a:r>
+          </a:p>
+          <a:p>
+            <a:pPr>
+              <a:spcAft>
+                <a:spcPts val="600"/>
+              </a:spcAft>
+            </a:pPr>
+            <a:r>
+              <a:rPr b="1" sz="1400">
+                <a:solidFill>
+                  <a:srgbClr val="2C7FB8"/>
+                </a:solidFill>
+              </a:rPr>
+              <a:t>why N:  </a:t>
+            </a:r>
+            <a:r>
+              <a:rPr sz="1400">
+                <a:solidFill>
+                  <a:srgbClr val="0F172A"/>
+                </a:solidFill>
+              </a:rPr>
+              <a:t>Four elevation bands give surface-data (soil/PFT) spanning across the basin; sampling ~2 columns per band (dominant + secondary soil where heterogeneity exists once gridded soil is ingested) yields 8. This is NOT an elevation/climate test — forcing is uniform — it spans surface heterogeneity. The forcing-period axis (baseline/wet/drought) is applied as a treatment over the same columns, not as extra columns, to probe partitioning sensitivity to climate variability.</a:t>
+            </a:r>
+          </a:p>
+          <a:p>
+            <a:pPr>
+              <a:spcAft>
+                <a:spcPts val="600"/>
+              </a:spcAft>
+            </a:pPr>
+            <a:r>
+              <a:rPr b="1" sz="1400">
+                <a:solidFill>
+                  <a:srgbClr val="2C7FB8"/>
+                </a:solidFill>
+              </a:rPr>
+              <a:t>feasibility:  </a:t>
+            </a:r>
+            <a:r>
+              <a:rPr sz="1400">
+                <a:solidFill>
+                  <a:srgbClr val="0F172A"/>
+                </a:solidFill>
+              </a:rPr>
+              <a:t>partial</a:t>
+            </a:r>
+          </a:p>
+          <a:p>
+            <a:pPr>
+              <a:spcAft>
+                <a:spcPts val="600"/>
+              </a:spcAft>
+            </a:pPr>
+            <a:r>
+              <a:rPr b="1" sz="1400">
+                <a:solidFill>
+                  <a:srgbClr val="2C7FB8"/>
+                </a:solidFill>
+              </a:rPr>
+              <a:t>not answerable:  </a:t>
+            </a:r>
+            <a:r>
+              <a:rPr sz="1400">
+                <a:solidFill>
+                  <a:srgbClr val="0F172A"/>
+                </a:solidFill>
+              </a:rPr>
+              <a:t>Elevation/climate-gradient control on partitioning (snow-dominated headwaters vs. semi-arid lowland) — needs elevation-downscaled forcing</a:t>
+            </a:r>
+          </a:p>
+          <a:p>
+            <a:pPr>
+              <a:spcAft>
+                <a:spcPts val="600"/>
+              </a:spcAft>
+            </a:pPr>
+            <a:r>
+              <a:rPr b="1" sz="1400">
+                <a:solidFill>
+                  <a:srgbClr val="2C7FB8"/>
+                </a:solidFill>
+              </a:rPr>
+              <a:t>not answerable:  </a:t>
+            </a:r>
+            <a:r>
+              <a:rPr sz="1400">
+                <a:solidFill>
+                  <a:srgbClr val="0F172A"/>
+                </a:solidFill>
+              </a:rPr>
+              <a:t>SNOTEL SWE / montane snowpack validation — needs elevation-downscaled forcing + snow/SWE history output</a:t>
+            </a:r>
+          </a:p>
+        </p:txBody>
+      </p:sp>
     </p:spTree>
   </p:cSld>
   <p:clrMapOvr>
@@ -4049,14 +4066,14 @@
                   <a:srgbClr val="0F172A"/>
                 </a:solidFill>
               </a:rPr>
-              <a:t>Walla Walla — results (continued)</a:t>
+              <a:t>Walla Walla — sampling design (Tier-2 expander)</a:t>
             </a:r>
           </a:p>
         </p:txBody>
       </p:sp>
       <p:pic>
         <p:nvPicPr>
-          <p:cNvPr id="3" name="Picture 2" descr="debug_timeseries.png"/>
+          <p:cNvPr id="3" name="Picture 2" descr="sampling_design.png"/>
           <p:cNvPicPr>
             <a:picLocks noChangeAspect="1"/>
           </p:cNvPicPr>
@@ -4070,8 +4087,8 @@
         </p:blipFill>
         <p:spPr>
           <a:xfrm>
-            <a:off x="472287" y="1188720"/>
-            <a:ext cx="11247120" cy="4183902"/>
+            <a:off x="2067408" y="1051560"/>
+            <a:ext cx="8056879" cy="5577840"/>
           </a:xfrm>
           <a:prstGeom prst="rect">
             <a:avLst/>
@@ -4129,7 +4146,7 @@
                   <a:srgbClr val="0F172A"/>
                 </a:solidFill>
               </a:rPr>
-              <a:t>Walla Walla — analyzer interpretation</a:t>
+              <a:t>Walla Walla — execution &amp; results</a:t>
             </a:r>
           </a:p>
         </p:txBody>
@@ -4142,8 +4159,8 @@
         </p:nvSpPr>
         <p:spPr>
           <a:xfrm>
-            <a:off x="457200" y="1188720"/>
-            <a:ext cx="11277295" cy="5303520"/>
+            <a:off x="457200" y="1005840"/>
+            <a:ext cx="11277295" cy="457200"/>
           </a:xfrm>
           <a:prstGeom prst="rect">
             <a:avLst/>
@@ -4167,7 +4184,7 @@
                   <a:srgbClr val="2C7FB8"/>
                 </a:solidFill>
               </a:rPr>
-              <a:t>finding:  </a:t>
+              <a:t>execution:  </a:t>
             </a:r>
             <a:r>
               <a:rPr sz="1400">
@@ -4175,126 +4192,59 @@
                   <a:srgbClr val="0F172A"/>
                 </a:solidFill>
               </a:rPr>
-              <a:t>precip is quantized to 1 value(s) [530] mm/yr — coarse DATM forcing, NOT elevation-resolved</a:t>
-            </a:r>
-          </a:p>
-          <a:p>
-            <a:pPr>
-              <a:spcAft>
-                <a:spcPts val="600"/>
-              </a:spcAft>
-            </a:pPr>
-            <a:r>
-              <a:rPr b="1" sz="1400">
-                <a:solidFill>
-                  <a:srgbClr val="2C7FB8"/>
-                </a:solidFill>
-              </a:rPr>
-              <a:t>finding:  </a:t>
-            </a:r>
-            <a:r>
-              <a:rPr sz="1400">
-                <a:solidFill>
-                  <a:srgbClr val="0F172A"/>
-                </a:solidFill>
-              </a:rPr>
-              <a:t>linear elevation fit is weak (r2=0.196) — the elevation 'gradient' is not a reliable summary</a:t>
-            </a:r>
-          </a:p>
-          <a:p>
-            <a:pPr>
-              <a:spcAft>
-                <a:spcPts val="600"/>
-              </a:spcAft>
-            </a:pPr>
-            <a:r>
-              <a:rPr b="1" sz="1400">
-                <a:solidFill>
-                  <a:srgbClr val="2C7FB8"/>
-                </a:solidFill>
-              </a:rPr>
-              <a:t>finding:  </a:t>
-            </a:r>
-            <a:r>
-              <a:rPr sz="1400">
-                <a:solidFill>
-                  <a:srgbClr val="0F172A"/>
-                </a:solidFill>
-              </a:rPr>
-              <a:t>soil control (forcing held at 530 mm/yr, 8 columns): strongest predictor = recharge_vs_ksat_min (r=0.993)</a:t>
-            </a:r>
-          </a:p>
-          <a:p>
-            <a:pPr>
-              <a:spcAft>
-                <a:spcPts val="600"/>
-              </a:spcAft>
-            </a:pPr>
-            <a:r>
-              <a:rPr b="1" sz="1400">
-                <a:solidFill>
-                  <a:srgbClr val="2C7FB8"/>
-                </a:solidFill>
-              </a:rPr>
-              <a:t>finding:  </a:t>
-            </a:r>
-            <a:r>
-              <a:rPr sz="1400">
-                <a:solidFill>
-                  <a:srgbClr val="0F172A"/>
-                </a:solidFill>
-              </a:rPr>
-              <a:t>[COMPARED] water-table depth: model ZWT mean 8.78 m vs Fan 53.93 m (bias -45.15 m)</a:t>
-            </a:r>
-          </a:p>
-          <a:p>
-            <a:pPr>
-              <a:spcAft>
-                <a:spcPts val="600"/>
-              </a:spcAft>
-            </a:pPr>
-            <a:r>
-              <a:rPr b="1" sz="1400">
-                <a:solidFill>
-                  <a:srgbClr val="2C7FB8"/>
-                </a:solidFill>
-              </a:rPr>
-              <a:t>finding:  </a:t>
-            </a:r>
-            <a:r>
-              <a:rPr sz="1400">
-                <a:solidFill>
-                  <a:srgbClr val="0F172A"/>
-                </a:solidFill>
-              </a:rPr>
-              <a:t>[context-only] integrated streamflow: modeled basin water yield (runoff+recharge) ≈ 42.4 mm/yr (reference; a single column produces no routed streamflow)</a:t>
-            </a:r>
-          </a:p>
-          <a:p>
-            <a:pPr>
-              <a:spcAft>
-                <a:spcPts val="600"/>
-              </a:spcAft>
-            </a:pPr>
-            <a:r>
-              <a:rPr b="1" sz="1400">
-                <a:solidFill>
-                  <a:srgbClr val="2C7FB8"/>
-                </a:solidFill>
-              </a:rPr>
-              <a:t>finding:  </a:t>
-            </a:r>
-            <a:r>
-              <a:rPr sz="1400">
-                <a:solidFill>
-                  <a:srgbClr val="0F172A"/>
-                </a:solidFill>
-              </a:rPr>
-              <a:t>[context-only] snow water equivalent: SNOTEL stations present, but the run has no SWE output to compare</a:t>
-            </a:r>
-          </a:p>
-        </p:txBody>
-      </p:sp>
+              <a:t>4/4 columns succeeded · ~7 min each (~15 s clone per column, shared executable)</a:t>
+            </a:r>
+          </a:p>
+        </p:txBody>
+      </p:sp>
+      <p:pic>
+        <p:nvPicPr>
+          <p:cNvPr id="4" name="Picture 3" descr="elevation_gradient.png"/>
+          <p:cNvPicPr>
+            <a:picLocks noChangeAspect="1"/>
+          </p:cNvPicPr>
+          <p:nvPr/>
+        </p:nvPicPr>
+        <p:blipFill>
+          <a:blip r:embed="rId2"/>
+          <a:stretch>
+            <a:fillRect/>
+          </a:stretch>
+        </p:blipFill>
+        <p:spPr>
+          <a:xfrm>
+            <a:off x="2181260" y="1600200"/>
+            <a:ext cx="7829174" cy="2514600"/>
+          </a:xfrm>
+          <a:prstGeom prst="rect">
+            <a:avLst/>
+          </a:prstGeom>
+        </p:spPr>
+      </p:pic>
+      <p:pic>
+        <p:nvPicPr>
+          <p:cNvPr id="5" name="Picture 4" descr="soil_control.png"/>
+          <p:cNvPicPr>
+            <a:picLocks noChangeAspect="1"/>
+          </p:cNvPicPr>
+          <p:nvPr/>
+        </p:nvPicPr>
+        <p:blipFill>
+          <a:blip r:embed="rId3"/>
+          <a:stretch>
+            <a:fillRect/>
+          </a:stretch>
+        </p:blipFill>
+        <p:spPr>
+          <a:xfrm>
+            <a:off x="3390104" y="4251960"/>
+            <a:ext cx="5411487" cy="2514600"/>
+          </a:xfrm>
+          <a:prstGeom prst="rect">
+            <a:avLst/>
+          </a:prstGeom>
+        </p:spPr>
+      </p:pic>
     </p:spTree>
   </p:cSld>
   <p:clrMapOvr>
@@ -4346,133 +4296,35 @@
                   <a:srgbClr val="0F172A"/>
                 </a:solidFill>
               </a:rPr>
-              <a:t>Case 4 — Controlled soil sweep</a:t>
-            </a:r>
-          </a:p>
-        </p:txBody>
-      </p:sp>
-      <p:sp>
-        <p:nvSpPr>
-          <p:cNvPr id="3" name="TextBox 2"/>
-          <p:cNvSpPr txBox="1"/>
+              <a:t>Walla Walla — results (continued)</a:t>
+            </a:r>
+          </a:p>
+        </p:txBody>
+      </p:sp>
+      <p:pic>
+        <p:nvPicPr>
+          <p:cNvPr id="3" name="Picture 2" descr="debug_timeseries.png"/>
+          <p:cNvPicPr>
+            <a:picLocks noChangeAspect="1"/>
+          </p:cNvPicPr>
           <p:nvPr/>
-        </p:nvSpPr>
-        <p:spPr>
-          <a:xfrm>
-            <a:off x="457200" y="868680"/>
-            <a:ext cx="11277295" cy="365760"/>
+        </p:nvPicPr>
+        <p:blipFill>
+          <a:blip r:embed="rId2"/>
+          <a:stretch>
+            <a:fillRect/>
+          </a:stretch>
+        </p:blipFill>
+        <p:spPr>
+          <a:xfrm>
+            <a:off x="472287" y="1188720"/>
+            <a:ext cx="11247120" cy="4183902"/>
           </a:xfrm>
           <a:prstGeom prst="rect">
             <a:avLst/>
           </a:prstGeom>
-          <a:noFill/>
-        </p:spPr>
-        <p:txBody>
-          <a:bodyPr wrap="square">
-            <a:spAutoFit/>
-          </a:bodyPr>
-          <a:lstStyle/>
-          <a:p>
-            <a:pPr>
-              <a:spcAft>
-                <a:spcPts val="600"/>
-              </a:spcAft>
-            </a:pPr>
-            <a:r>
-              <a:rPr sz="1300" b="0">
-                <a:solidFill>
-                  <a:srgbClr val="475569"/>
-                </a:solidFill>
-              </a:rPr>
-              <a:t>7 uniform-soil treatments (clay05, clay10, clay18, clay27, clay35, clay45, clay55) at one site — forcing, vegetation and location held identical</a:t>
-            </a:r>
-          </a:p>
-        </p:txBody>
-      </p:sp>
-      <p:sp>
-        <p:nvSpPr>
-          <p:cNvPr id="4" name="TextBox 3"/>
-          <p:cNvSpPr txBox="1"/>
-          <p:nvPr/>
-        </p:nvSpPr>
-        <p:spPr>
-          <a:xfrm>
-            <a:off x="457200" y="1371600"/>
-            <a:ext cx="11277295" cy="1005840"/>
-          </a:xfrm>
-          <a:prstGeom prst="rect">
-            <a:avLst/>
-          </a:prstGeom>
-          <a:noFill/>
-        </p:spPr>
-        <p:txBody>
-          <a:bodyPr wrap="square">
-            <a:spAutoFit/>
-          </a:bodyPr>
-          <a:lstStyle/>
-          <a:p>
-            <a:pPr>
-              <a:spcAft>
-                <a:spcPts val="600"/>
-              </a:spcAft>
-            </a:pPr>
-            <a:r>
-              <a:rPr sz="1800" b="1">
-                <a:solidFill>
-                  <a:srgbClr val="2C7FB8"/>
-                </a:solidFill>
-              </a:rPr>
-              <a:t>“Controlled experiment: how does soil texture (clay content) control the runoff/recharge partitioning?”</a:t>
-            </a:r>
-          </a:p>
-        </p:txBody>
-      </p:sp>
-      <p:sp>
-        <p:nvSpPr>
-          <p:cNvPr id="5" name="TextBox 4"/>
-          <p:cNvSpPr txBox="1"/>
-          <p:nvPr/>
-        </p:nvSpPr>
-        <p:spPr>
-          <a:xfrm>
-            <a:off x="457200" y="2468880"/>
-            <a:ext cx="11277295" cy="3931920"/>
-          </a:xfrm>
-          <a:prstGeom prst="rect">
-            <a:avLst/>
-          </a:prstGeom>
-          <a:noFill/>
-        </p:spPr>
-        <p:txBody>
-          <a:bodyPr wrap="square">
-            <a:spAutoFit/>
-          </a:bodyPr>
-          <a:lstStyle/>
-          <a:p>
-            <a:pPr>
-              <a:spcAft>
-                <a:spcPts val="600"/>
-              </a:spcAft>
-            </a:pPr>
-            <a:r>
-              <a:rPr b="1" sz="1400">
-                <a:solidFill>
-                  <a:srgbClr val="2C7FB8"/>
-                </a:solidFill>
-              </a:rPr>
-              <a:t>design:  </a:t>
-            </a:r>
-            <a:r>
-              <a:rPr sz="1400">
-                <a:solidFill>
-                  <a:srgbClr val="0F172A"/>
-                </a:solidFill>
-              </a:rPr>
-              <a:t>conceptual archetype — vary ONE factor (clay 5→55%), hold everything else fixed; the cleanest isolation of soil control</a:t>
-            </a:r>
-          </a:p>
-        </p:txBody>
-      </p:sp>
+        </p:spPr>
+      </p:pic>
     </p:spTree>
   </p:cSld>
   <p:clrMapOvr>
@@ -4524,7 +4376,7 @@
                   <a:srgbClr val="0F172A"/>
                 </a:solidFill>
               </a:rPr>
-              <a:t>Controlled soil sweep — execution &amp; results</a:t>
+              <a:t>Walla Walla — analyzer interpretation</a:t>
             </a:r>
           </a:p>
         </p:txBody>
@@ -4537,8 +4389,8 @@
         </p:nvSpPr>
         <p:spPr>
           <a:xfrm>
-            <a:off x="457200" y="1005840"/>
-            <a:ext cx="11277295" cy="457200"/>
+            <a:off x="457200" y="1188720"/>
+            <a:ext cx="11277295" cy="5303520"/>
           </a:xfrm>
           <a:prstGeom prst="rect">
             <a:avLst/>
@@ -4562,7 +4414,7 @@
                   <a:srgbClr val="2C7FB8"/>
                 </a:solidFill>
               </a:rPr>
-              <a:t>execution:  </a:t>
+              <a:t>finding:  </a:t>
             </a:r>
             <a:r>
               <a:rPr sz="1400">
@@ -4570,59 +4422,57 @@
                   <a:srgbClr val="0F172A"/>
                 </a:solidFill>
               </a:rPr>
-              <a:t>7/7 columns succeeded · ~3 min each (~15 s clone per column, shared executable)</a:t>
-            </a:r>
-          </a:p>
-        </p:txBody>
-      </p:sp>
-      <p:pic>
-        <p:nvPicPr>
-          <p:cNvPr id="4" name="Picture 3" descr="soil_control.png"/>
-          <p:cNvPicPr>
-            <a:picLocks noChangeAspect="1"/>
-          </p:cNvPicPr>
-          <p:nvPr/>
-        </p:nvPicPr>
-        <p:blipFill>
-          <a:blip r:embed="rId2"/>
-          <a:stretch>
-            <a:fillRect/>
-          </a:stretch>
-        </p:blipFill>
-        <p:spPr>
-          <a:xfrm>
-            <a:off x="3390104" y="1600200"/>
-            <a:ext cx="5411487" cy="2514600"/>
-          </a:xfrm>
-          <a:prstGeom prst="rect">
-            <a:avLst/>
-          </a:prstGeom>
-        </p:spPr>
-      </p:pic>
-      <p:pic>
-        <p:nvPicPr>
-          <p:cNvPr id="5" name="Picture 4" descr="debug_timeseries.png"/>
-          <p:cNvPicPr>
-            <a:picLocks noChangeAspect="1"/>
-          </p:cNvPicPr>
-          <p:nvPr/>
-        </p:nvPicPr>
-        <p:blipFill>
-          <a:blip r:embed="rId3"/>
-          <a:stretch>
-            <a:fillRect/>
-          </a:stretch>
-        </p:blipFill>
-        <p:spPr>
-          <a:xfrm>
-            <a:off x="2715987" y="4251960"/>
-            <a:ext cx="6759720" cy="2514600"/>
-          </a:xfrm>
-          <a:prstGeom prst="rect">
-            <a:avLst/>
-          </a:prstGeom>
-        </p:spPr>
-      </p:pic>
+              <a:t>precip is quantized to 1 value(s) [530] mm/yr — coarse DATM forcing, NOT elevation-resolved</a:t>
+            </a:r>
+          </a:p>
+          <a:p>
+            <a:pPr>
+              <a:spcAft>
+                <a:spcPts val="600"/>
+              </a:spcAft>
+            </a:pPr>
+            <a:r>
+              <a:rPr b="1" sz="1400">
+                <a:solidFill>
+                  <a:srgbClr val="2C7FB8"/>
+                </a:solidFill>
+              </a:rPr>
+              <a:t>finding:  </a:t>
+            </a:r>
+            <a:r>
+              <a:rPr sz="1400">
+                <a:solidFill>
+                  <a:srgbClr val="0F172A"/>
+                </a:solidFill>
+              </a:rPr>
+              <a:t>linear elevation fit is weak (r2=0.196) — the elevation 'gradient' is not a reliable summary</a:t>
+            </a:r>
+          </a:p>
+          <a:p>
+            <a:pPr>
+              <a:spcAft>
+                <a:spcPts val="600"/>
+              </a:spcAft>
+            </a:pPr>
+            <a:r>
+              <a:rPr b="1" sz="1400">
+                <a:solidFill>
+                  <a:srgbClr val="2C7FB8"/>
+                </a:solidFill>
+              </a:rPr>
+              <a:t>finding:  </a:t>
+            </a:r>
+            <a:r>
+              <a:rPr sz="1400">
+                <a:solidFill>
+                  <a:srgbClr val="0F172A"/>
+                </a:solidFill>
+              </a:rPr>
+              <a:t>soil control (forcing held at 530 mm/yr, 8 columns): strongest predictor = recharge_vs_ksat_min (r=0.993)</a:t>
+            </a:r>
+          </a:p>
+        </p:txBody>
+      </p:sp>
     </p:spTree>
   </p:cSld>
   <p:clrMapOvr>
@@ -4674,7 +4524,7 @@
                   <a:srgbClr val="0F172A"/>
                 </a:solidFill>
               </a:rPr>
-              <a:t>Controlled soil sweep — analyzer interpretation</a:t>
+              <a:t>Walla Walla — evaluation vs observations</a:t>
             </a:r>
           </a:p>
         </p:txBody>
@@ -4687,8 +4537,8 @@
         </p:nvSpPr>
         <p:spPr>
           <a:xfrm>
-            <a:off x="457200" y="1188720"/>
-            <a:ext cx="11277295" cy="5303520"/>
+            <a:off x="457200" y="868680"/>
+            <a:ext cx="11277295" cy="365760"/>
           </a:xfrm>
           <a:prstGeom prst="rect">
             <a:avLst/>
@@ -4707,24 +4557,155 @@
               </a:spcAft>
             </a:pPr>
             <a:r>
-              <a:rPr b="1" sz="1400">
+              <a:rPr sz="1300" b="0">
+                <a:solidFill>
+                  <a:srgbClr val="475569"/>
+                </a:solidFill>
+              </a:rPr>
+              <a:t>what could be compared honestly, and what still blocks rigorous validation</a:t>
+            </a:r>
+          </a:p>
+        </p:txBody>
+      </p:sp>
+      <p:sp>
+        <p:nvSpPr>
+          <p:cNvPr id="4" name="TextBox 3"/>
+          <p:cNvSpPr txBox="1"/>
+          <p:nvPr/>
+        </p:nvSpPr>
+        <p:spPr>
+          <a:xfrm>
+            <a:off x="457200" y="1143000"/>
+            <a:ext cx="11277295" cy="2194560"/>
+          </a:xfrm>
+          <a:prstGeom prst="rect">
+            <a:avLst/>
+          </a:prstGeom>
+          <a:noFill/>
+        </p:spPr>
+        <p:txBody>
+          <a:bodyPr wrap="square">
+            <a:spAutoFit/>
+          </a:bodyPr>
+          <a:lstStyle/>
+          <a:p>
+            <a:pPr>
+              <a:spcAft>
+                <a:spcPts val="600"/>
+              </a:spcAft>
+            </a:pPr>
+            <a:r>
+              <a:rPr b="1" sz="1300">
                 <a:solidFill>
                   <a:srgbClr val="2C7FB8"/>
                 </a:solidFill>
               </a:rPr>
-              <a:t>finding:  </a:t>
-            </a:r>
-            <a:r>
-              <a:rPr sz="1400">
+              <a:t>in-domain obs:  </a:t>
+            </a:r>
+            <a:r>
+              <a:rPr sz="1300">
                 <a:solidFill>
                   <a:srgbClr val="0F172A"/>
                 </a:solidFill>
               </a:rPr>
-              <a:t>soil control (forcing held at 1373 mm/yr, 7 columns): strongest predictor = recharge_vs_clay_max (r=-0.932)</a:t>
-            </a:r>
-          </a:p>
-        </p:txBody>
-      </p:sp>
+              <a:t>SNOTEL 2 · stream gages 159 · GW wells 200 (2/6 sampled have records)</a:t>
+            </a:r>
+          </a:p>
+          <a:p>
+            <a:pPr>
+              <a:spcAft>
+                <a:spcPts val="600"/>
+              </a:spcAft>
+            </a:pPr>
+            <a:r>
+              <a:rPr b="1" sz="1300">
+                <a:solidFill>
+                  <a:srgbClr val="2C7FB8"/>
+                </a:solidFill>
+              </a:rPr>
+              <a:t>✓ COMPARED — water-table depth:  </a:t>
+            </a:r>
+            <a:r>
+              <a:rPr sz="1300">
+                <a:solidFill>
+                  <a:srgbClr val="0F172A"/>
+                </a:solidFill>
+              </a:rPr>
+              <a:t>model ZWT mean 8.78 m vs Fan 53.93 m (bias -45.15 m)</a:t>
+            </a:r>
+          </a:p>
+          <a:p>
+            <a:pPr>
+              <a:spcAft>
+                <a:spcPts val="600"/>
+              </a:spcAft>
+            </a:pPr>
+            <a:r>
+              <a:rPr b="1" sz="1300">
+                <a:solidFill>
+                  <a:srgbClr val="2C7FB8"/>
+                </a:solidFill>
+              </a:rPr>
+              <a:t>· context-only — integrated streamflow:  </a:t>
+            </a:r>
+            <a:r>
+              <a:rPr sz="1300">
+                <a:solidFill>
+                  <a:srgbClr val="0F172A"/>
+                </a:solidFill>
+              </a:rPr>
+              <a:t>modeled basin water yield (runoff+recharge) ≈ 42.4 mm/yr (reference; a single column produces no routed streamflow)  — needs: runoff routing / column aggregation</a:t>
+            </a:r>
+          </a:p>
+          <a:p>
+            <a:pPr>
+              <a:spcAft>
+                <a:spcPts val="600"/>
+              </a:spcAft>
+            </a:pPr>
+            <a:r>
+              <a:rPr b="1" sz="1300">
+                <a:solidFill>
+                  <a:srgbClr val="2C7FB8"/>
+                </a:solidFill>
+              </a:rPr>
+              <a:t>· context-only — snow water equivalent:  </a:t>
+            </a:r>
+            <a:r>
+              <a:rPr sz="1300">
+                <a:solidFill>
+                  <a:srgbClr val="0F172A"/>
+                </a:solidFill>
+              </a:rPr>
+              <a:t>SNOTEL stations present, but the run has no SWE output to compare  — needs: snow/SWE history output + elevation-downscaled forcing</a:t>
+            </a:r>
+          </a:p>
+        </p:txBody>
+      </p:sp>
+      <p:pic>
+        <p:nvPicPr>
+          <p:cNvPr id="5" name="Picture 4" descr="validation.png"/>
+          <p:cNvPicPr>
+            <a:picLocks noChangeAspect="1"/>
+          </p:cNvPicPr>
+          <p:nvPr/>
+        </p:nvPicPr>
+        <p:blipFill>
+          <a:blip r:embed="rId2"/>
+          <a:stretch>
+            <a:fillRect/>
+          </a:stretch>
+        </p:blipFill>
+        <p:spPr>
+          <a:xfrm>
+            <a:off x="2235985" y="3520440"/>
+            <a:ext cx="7719724" cy="3200400"/>
+          </a:xfrm>
+          <a:prstGeom prst="rect">
+            <a:avLst/>
+          </a:prstGeom>
+        </p:spPr>
+      </p:pic>
     </p:spTree>
   </p:cSld>
   <p:clrMapOvr>
@@ -4734,6 +4715,683 @@
 </file>
 
 <file path=ppt/slides/slide19.xml><?xml version="1.0" encoding="utf-8"?>
+<p:sld xmlns:a="http://schemas.openxmlformats.org/drawingml/2006/main" xmlns:p="http://schemas.openxmlformats.org/presentationml/2006/main" xmlns:r="http://schemas.openxmlformats.org/officeDocument/2006/relationships">
+  <p:cSld>
+    <p:spTree>
+      <p:nvGrpSpPr>
+        <p:cNvPr id="1" name=""/>
+        <p:cNvGrpSpPr/>
+        <p:nvPr/>
+      </p:nvGrpSpPr>
+      <p:grpSpPr/>
+      <p:sp>
+        <p:nvSpPr>
+          <p:cNvPr id="2" name="TextBox 1"/>
+          <p:cNvSpPr txBox="1"/>
+          <p:nvPr/>
+        </p:nvSpPr>
+        <p:spPr>
+          <a:xfrm>
+            <a:off x="457200" y="228600"/>
+            <a:ext cx="11277295" cy="640080"/>
+          </a:xfrm>
+          <a:prstGeom prst="rect">
+            <a:avLst/>
+          </a:prstGeom>
+          <a:noFill/>
+        </p:spPr>
+        <p:txBody>
+          <a:bodyPr wrap="square">
+            <a:spAutoFit/>
+          </a:bodyPr>
+          <a:lstStyle/>
+          <a:p>
+            <a:pPr>
+              <a:spcAft>
+                <a:spcPts val="600"/>
+              </a:spcAft>
+            </a:pPr>
+            <a:r>
+              <a:rPr sz="2800" b="1">
+                <a:solidFill>
+                  <a:srgbClr val="0F172A"/>
+                </a:solidFill>
+              </a:rPr>
+              <a:t>Case 4 — Controlled soil sweep</a:t>
+            </a:r>
+          </a:p>
+        </p:txBody>
+      </p:sp>
+      <p:sp>
+        <p:nvSpPr>
+          <p:cNvPr id="3" name="TextBox 2"/>
+          <p:cNvSpPr txBox="1"/>
+          <p:nvPr/>
+        </p:nvSpPr>
+        <p:spPr>
+          <a:xfrm>
+            <a:off x="457200" y="868680"/>
+            <a:ext cx="11277295" cy="365760"/>
+          </a:xfrm>
+          <a:prstGeom prst="rect">
+            <a:avLst/>
+          </a:prstGeom>
+          <a:noFill/>
+        </p:spPr>
+        <p:txBody>
+          <a:bodyPr wrap="square">
+            <a:spAutoFit/>
+          </a:bodyPr>
+          <a:lstStyle/>
+          <a:p>
+            <a:pPr>
+              <a:spcAft>
+                <a:spcPts val="600"/>
+              </a:spcAft>
+            </a:pPr>
+            <a:r>
+              <a:rPr sz="1300" b="0">
+                <a:solidFill>
+                  <a:srgbClr val="475569"/>
+                </a:solidFill>
+              </a:rPr>
+              <a:t>7 uniform-soil treatments (clay05, clay10, clay18, clay27, clay35, clay45, clay55) at one site — forcing, vegetation and location held identical</a:t>
+            </a:r>
+          </a:p>
+        </p:txBody>
+      </p:sp>
+      <p:sp>
+        <p:nvSpPr>
+          <p:cNvPr id="4" name="TextBox 3"/>
+          <p:cNvSpPr txBox="1"/>
+          <p:nvPr/>
+        </p:nvSpPr>
+        <p:spPr>
+          <a:xfrm>
+            <a:off x="457200" y="1371600"/>
+            <a:ext cx="11277295" cy="1005840"/>
+          </a:xfrm>
+          <a:prstGeom prst="rect">
+            <a:avLst/>
+          </a:prstGeom>
+          <a:noFill/>
+        </p:spPr>
+        <p:txBody>
+          <a:bodyPr wrap="square">
+            <a:spAutoFit/>
+          </a:bodyPr>
+          <a:lstStyle/>
+          <a:p>
+            <a:pPr>
+              <a:spcAft>
+                <a:spcPts val="600"/>
+              </a:spcAft>
+            </a:pPr>
+            <a:r>
+              <a:rPr sz="1800" b="1">
+                <a:solidFill>
+                  <a:srgbClr val="2C7FB8"/>
+                </a:solidFill>
+              </a:rPr>
+              <a:t>“Controlled experiment: how does soil texture (clay content) control the runoff/recharge partitioning?”</a:t>
+            </a:r>
+          </a:p>
+        </p:txBody>
+      </p:sp>
+      <p:sp>
+        <p:nvSpPr>
+          <p:cNvPr id="5" name="TextBox 4"/>
+          <p:cNvSpPr txBox="1"/>
+          <p:nvPr/>
+        </p:nvSpPr>
+        <p:spPr>
+          <a:xfrm>
+            <a:off x="457200" y="2468880"/>
+            <a:ext cx="11277295" cy="3931920"/>
+          </a:xfrm>
+          <a:prstGeom prst="rect">
+            <a:avLst/>
+          </a:prstGeom>
+          <a:noFill/>
+        </p:spPr>
+        <p:txBody>
+          <a:bodyPr wrap="square">
+            <a:spAutoFit/>
+          </a:bodyPr>
+          <a:lstStyle/>
+          <a:p>
+            <a:pPr>
+              <a:spcAft>
+                <a:spcPts val="600"/>
+              </a:spcAft>
+            </a:pPr>
+            <a:r>
+              <a:rPr b="1" sz="1400">
+                <a:solidFill>
+                  <a:srgbClr val="2C7FB8"/>
+                </a:solidFill>
+              </a:rPr>
+              <a:t>design:  </a:t>
+            </a:r>
+            <a:r>
+              <a:rPr sz="1400">
+                <a:solidFill>
+                  <a:srgbClr val="0F172A"/>
+                </a:solidFill>
+              </a:rPr>
+              <a:t>conceptual archetype — vary ONE factor (clay 5→55%), hold everything else fixed; the cleanest isolation of soil control</a:t>
+            </a:r>
+          </a:p>
+        </p:txBody>
+      </p:sp>
+    </p:spTree>
+  </p:cSld>
+  <p:clrMapOvr>
+    <a:masterClrMapping/>
+  </p:clrMapOvr>
+</p:sld>
+</file>
+
+<file path=ppt/slides/slide2.xml><?xml version="1.0" encoding="utf-8"?>
+<p:sld xmlns:a="http://schemas.openxmlformats.org/drawingml/2006/main" xmlns:p="http://schemas.openxmlformats.org/presentationml/2006/main" xmlns:r="http://schemas.openxmlformats.org/officeDocument/2006/relationships">
+  <p:cSld>
+    <p:spTree>
+      <p:nvGrpSpPr>
+        <p:cNvPr id="1" name=""/>
+        <p:cNvGrpSpPr/>
+        <p:nvPr/>
+      </p:nvGrpSpPr>
+      <p:grpSpPr/>
+      <p:sp>
+        <p:nvSpPr>
+          <p:cNvPr id="2" name="TextBox 1"/>
+          <p:cNvSpPr txBox="1"/>
+          <p:nvPr/>
+        </p:nvSpPr>
+        <p:spPr>
+          <a:xfrm>
+            <a:off x="457200" y="228600"/>
+            <a:ext cx="11277295" cy="640080"/>
+          </a:xfrm>
+          <a:prstGeom prst="rect">
+            <a:avLst/>
+          </a:prstGeom>
+          <a:noFill/>
+        </p:spPr>
+        <p:txBody>
+          <a:bodyPr wrap="square">
+            <a:spAutoFit/>
+          </a:bodyPr>
+          <a:lstStyle/>
+          <a:p>
+            <a:pPr>
+              <a:spcAft>
+                <a:spcPts val="600"/>
+              </a:spcAft>
+            </a:pPr>
+            <a:r>
+              <a:rPr sz="2800" b="1">
+                <a:solidFill>
+                  <a:srgbClr val="0F172A"/>
+                </a:solidFill>
+              </a:rPr>
+              <a:t>Case 1 — Naches</a:t>
+            </a:r>
+          </a:p>
+        </p:txBody>
+      </p:sp>
+      <p:sp>
+        <p:nvSpPr>
+          <p:cNvPr id="3" name="TextBox 2"/>
+          <p:cNvSpPr txBox="1"/>
+          <p:nvPr/>
+        </p:nvSpPr>
+        <p:spPr>
+          <a:xfrm>
+            <a:off x="457200" y="868680"/>
+            <a:ext cx="11277295" cy="365760"/>
+          </a:xfrm>
+          <a:prstGeom prst="rect">
+            <a:avLst/>
+          </a:prstGeom>
+          <a:noFill/>
+        </p:spPr>
+        <p:txBody>
+          <a:bodyPr wrap="square">
+            <a:spAutoFit/>
+          </a:bodyPr>
+          <a:lstStyle/>
+          <a:p>
+            <a:pPr>
+              <a:spcAft>
+                <a:spcPts val="600"/>
+              </a:spcAft>
+            </a:pPr>
+            <a:r>
+              <a:rPr sz="1300" b="0">
+                <a:solidFill>
+                  <a:srgbClr val="475569"/>
+                </a:solidFill>
+              </a:rPr>
+              <a:t>HUC 17030002 · 2860.6 km² · elevation 352.0–1977.4 m</a:t>
+            </a:r>
+          </a:p>
+        </p:txBody>
+      </p:sp>
+      <p:sp>
+        <p:nvSpPr>
+          <p:cNvPr id="4" name="TextBox 3"/>
+          <p:cNvSpPr txBox="1"/>
+          <p:nvPr/>
+        </p:nvSpPr>
+        <p:spPr>
+          <a:xfrm>
+            <a:off x="457200" y="1371600"/>
+            <a:ext cx="11277295" cy="1005840"/>
+          </a:xfrm>
+          <a:prstGeom prst="rect">
+            <a:avLst/>
+          </a:prstGeom>
+          <a:noFill/>
+        </p:spPr>
+        <p:txBody>
+          <a:bodyPr wrap="square">
+            <a:spAutoFit/>
+          </a:bodyPr>
+          <a:lstStyle/>
+          <a:p>
+            <a:pPr>
+              <a:spcAft>
+                <a:spcPts val="600"/>
+              </a:spcAft>
+            </a:pPr>
+            <a:r>
+              <a:rPr sz="1800" b="1">
+                <a:solidFill>
+                  <a:srgbClr val="2C7FB8"/>
+                </a:solidFill>
+              </a:rPr>
+              <a:t>“Determine the partitioning of runoff, infiltration, and recharge and the processes that control it across the Naches sub-watershed (HUC8 17030002, eastern Cascades, WA), and validate against observations”</a:t>
+            </a:r>
+          </a:p>
+        </p:txBody>
+      </p:sp>
+      <p:sp>
+        <p:nvSpPr>
+          <p:cNvPr id="5" name="TextBox 4"/>
+          <p:cNvSpPr txBox="1"/>
+          <p:nvPr/>
+        </p:nvSpPr>
+        <p:spPr>
+          <a:xfrm>
+            <a:off x="457200" y="2468880"/>
+            <a:ext cx="11277295" cy="3931920"/>
+          </a:xfrm>
+          <a:prstGeom prst="rect">
+            <a:avLst/>
+          </a:prstGeom>
+          <a:noFill/>
+        </p:spPr>
+        <p:txBody>
+          <a:bodyPr wrap="square">
+            <a:spAutoFit/>
+          </a:bodyPr>
+          <a:lstStyle/>
+          <a:p>
+            <a:pPr>
+              <a:spcAft>
+                <a:spcPts val="600"/>
+              </a:spcAft>
+            </a:pPr>
+            <a:r>
+              <a:rPr b="1" sz="1400">
+                <a:solidFill>
+                  <a:srgbClr val="2C7FB8"/>
+                </a:solidFill>
+              </a:rPr>
+              <a:t>goal:  </a:t>
+            </a:r>
+            <a:r>
+              <a:rPr sz="1400">
+                <a:solidFill>
+                  <a:srgbClr val="0F172A"/>
+                </a:solidFill>
+              </a:rPr>
+              <a:t>Mechanistic: quantify partitioning of precip+snowmelt into surface runoff, infiltration, and deep drainage (recharge) across the Naches, and attribute it to elevation/snow regime, soil layering, and ET</a:t>
+            </a:r>
+          </a:p>
+          <a:p>
+            <a:pPr>
+              <a:spcAft>
+                <a:spcPts val="600"/>
+              </a:spcAft>
+            </a:pPr>
+            <a:r>
+              <a:rPr b="1" sz="1400">
+                <a:solidFill>
+                  <a:srgbClr val="2C7FB8"/>
+                </a:solidFill>
+              </a:rPr>
+              <a:t>goal:  </a:t>
+            </a:r>
+            <a:r>
+              <a:rPr sz="1400">
+                <a:solidFill>
+                  <a:srgbClr val="0F172A"/>
+                </a:solidFill>
+              </a:rPr>
+              <a:t>Validation: confront simulated SWE against SNOTEL and integrated runoff against USGS streamflow; treat recharge as an unvalidated water-balance residual</a:t>
+            </a:r>
+          </a:p>
+          <a:p>
+            <a:pPr>
+              <a:spcAft>
+                <a:spcPts val="600"/>
+              </a:spcAft>
+            </a:pPr>
+            <a:r>
+              <a:rPr b="1" sz="1400">
+                <a:solidFill>
+                  <a:srgbClr val="2C7FB8"/>
+                </a:solidFill>
+              </a:rPr>
+              <a:t>sampling:  </a:t>
+            </a:r>
+            <a:r>
+              <a:rPr sz="1400">
+                <a:solidFill>
+                  <a:srgbClr val="0F172A"/>
+                </a:solidFill>
+              </a:rPr>
+              <a:t>N=10 — stratified (elevation primary, soil-layering secondary) with validation columns pinned to observation sites</a:t>
+            </a:r>
+          </a:p>
+          <a:p>
+            <a:pPr>
+              <a:spcAft>
+                <a:spcPts val="600"/>
+              </a:spcAft>
+            </a:pPr>
+            <a:r>
+              <a:rPr b="1" sz="1400">
+                <a:solidFill>
+                  <a:srgbClr val="2C7FB8"/>
+                </a:solidFill>
+              </a:rPr>
+              <a:t>why N:  </a:t>
+            </a:r>
+            <a:r>
+              <a:rPr sz="1400">
+                <a:solidFill>
+                  <a:srgbClr val="0F172A"/>
+                </a:solidFill>
+              </a:rPr>
+              <a:t>4 elevation bands x 2 soil contrasts = 8 to span the dominant snow-regime gradient and the infiltration-vs-recharge soil control, +2 replicates at the rain-snow transition (bands 2-3) where partitioning is most sensitive. Soil kept to 2 levels because only point SSURGO exists (gridded soil is a gap).</a:t>
+            </a:r>
+          </a:p>
+        </p:txBody>
+      </p:sp>
+    </p:spTree>
+  </p:cSld>
+  <p:clrMapOvr>
+    <a:masterClrMapping/>
+  </p:clrMapOvr>
+</p:sld>
+</file>
+
+<file path=ppt/slides/slide20.xml><?xml version="1.0" encoding="utf-8"?>
+<p:sld xmlns:a="http://schemas.openxmlformats.org/drawingml/2006/main" xmlns:p="http://schemas.openxmlformats.org/presentationml/2006/main" xmlns:r="http://schemas.openxmlformats.org/officeDocument/2006/relationships">
+  <p:cSld>
+    <p:spTree>
+      <p:nvGrpSpPr>
+        <p:cNvPr id="1" name=""/>
+        <p:cNvGrpSpPr/>
+        <p:nvPr/>
+      </p:nvGrpSpPr>
+      <p:grpSpPr/>
+      <p:sp>
+        <p:nvSpPr>
+          <p:cNvPr id="2" name="TextBox 1"/>
+          <p:cNvSpPr txBox="1"/>
+          <p:nvPr/>
+        </p:nvSpPr>
+        <p:spPr>
+          <a:xfrm>
+            <a:off x="457200" y="228600"/>
+            <a:ext cx="11277295" cy="640080"/>
+          </a:xfrm>
+          <a:prstGeom prst="rect">
+            <a:avLst/>
+          </a:prstGeom>
+          <a:noFill/>
+        </p:spPr>
+        <p:txBody>
+          <a:bodyPr wrap="square">
+            <a:spAutoFit/>
+          </a:bodyPr>
+          <a:lstStyle/>
+          <a:p>
+            <a:pPr>
+              <a:spcAft>
+                <a:spcPts val="600"/>
+              </a:spcAft>
+            </a:pPr>
+            <a:r>
+              <a:rPr sz="2800" b="1">
+                <a:solidFill>
+                  <a:srgbClr val="0F172A"/>
+                </a:solidFill>
+              </a:rPr>
+              <a:t>Controlled soil sweep — execution &amp; results</a:t>
+            </a:r>
+          </a:p>
+        </p:txBody>
+      </p:sp>
+      <p:sp>
+        <p:nvSpPr>
+          <p:cNvPr id="3" name="TextBox 2"/>
+          <p:cNvSpPr txBox="1"/>
+          <p:nvPr/>
+        </p:nvSpPr>
+        <p:spPr>
+          <a:xfrm>
+            <a:off x="457200" y="1005840"/>
+            <a:ext cx="11277295" cy="457200"/>
+          </a:xfrm>
+          <a:prstGeom prst="rect">
+            <a:avLst/>
+          </a:prstGeom>
+          <a:noFill/>
+        </p:spPr>
+        <p:txBody>
+          <a:bodyPr wrap="square">
+            <a:spAutoFit/>
+          </a:bodyPr>
+          <a:lstStyle/>
+          <a:p>
+            <a:pPr>
+              <a:spcAft>
+                <a:spcPts val="600"/>
+              </a:spcAft>
+            </a:pPr>
+            <a:r>
+              <a:rPr b="1" sz="1400">
+                <a:solidFill>
+                  <a:srgbClr val="2C7FB8"/>
+                </a:solidFill>
+              </a:rPr>
+              <a:t>execution:  </a:t>
+            </a:r>
+            <a:r>
+              <a:rPr sz="1400">
+                <a:solidFill>
+                  <a:srgbClr val="0F172A"/>
+                </a:solidFill>
+              </a:rPr>
+              <a:t>7/7 columns succeeded · ~3 min each (~15 s clone per column, shared executable)</a:t>
+            </a:r>
+          </a:p>
+        </p:txBody>
+      </p:sp>
+      <p:pic>
+        <p:nvPicPr>
+          <p:cNvPr id="4" name="Picture 3" descr="soil_control.png"/>
+          <p:cNvPicPr>
+            <a:picLocks noChangeAspect="1"/>
+          </p:cNvPicPr>
+          <p:nvPr/>
+        </p:nvPicPr>
+        <p:blipFill>
+          <a:blip r:embed="rId2"/>
+          <a:stretch>
+            <a:fillRect/>
+          </a:stretch>
+        </p:blipFill>
+        <p:spPr>
+          <a:xfrm>
+            <a:off x="3390104" y="1600200"/>
+            <a:ext cx="5411487" cy="2514600"/>
+          </a:xfrm>
+          <a:prstGeom prst="rect">
+            <a:avLst/>
+          </a:prstGeom>
+        </p:spPr>
+      </p:pic>
+      <p:pic>
+        <p:nvPicPr>
+          <p:cNvPr id="5" name="Picture 4" descr="debug_timeseries.png"/>
+          <p:cNvPicPr>
+            <a:picLocks noChangeAspect="1"/>
+          </p:cNvPicPr>
+          <p:nvPr/>
+        </p:nvPicPr>
+        <p:blipFill>
+          <a:blip r:embed="rId3"/>
+          <a:stretch>
+            <a:fillRect/>
+          </a:stretch>
+        </p:blipFill>
+        <p:spPr>
+          <a:xfrm>
+            <a:off x="2715987" y="4251960"/>
+            <a:ext cx="6759720" cy="2514600"/>
+          </a:xfrm>
+          <a:prstGeom prst="rect">
+            <a:avLst/>
+          </a:prstGeom>
+        </p:spPr>
+      </p:pic>
+    </p:spTree>
+  </p:cSld>
+  <p:clrMapOvr>
+    <a:masterClrMapping/>
+  </p:clrMapOvr>
+</p:sld>
+</file>
+
+<file path=ppt/slides/slide21.xml><?xml version="1.0" encoding="utf-8"?>
+<p:sld xmlns:a="http://schemas.openxmlformats.org/drawingml/2006/main" xmlns:p="http://schemas.openxmlformats.org/presentationml/2006/main" xmlns:r="http://schemas.openxmlformats.org/officeDocument/2006/relationships">
+  <p:cSld>
+    <p:spTree>
+      <p:nvGrpSpPr>
+        <p:cNvPr id="1" name=""/>
+        <p:cNvGrpSpPr/>
+        <p:nvPr/>
+      </p:nvGrpSpPr>
+      <p:grpSpPr/>
+      <p:sp>
+        <p:nvSpPr>
+          <p:cNvPr id="2" name="TextBox 1"/>
+          <p:cNvSpPr txBox="1"/>
+          <p:nvPr/>
+        </p:nvSpPr>
+        <p:spPr>
+          <a:xfrm>
+            <a:off x="457200" y="228600"/>
+            <a:ext cx="11277295" cy="640080"/>
+          </a:xfrm>
+          <a:prstGeom prst="rect">
+            <a:avLst/>
+          </a:prstGeom>
+          <a:noFill/>
+        </p:spPr>
+        <p:txBody>
+          <a:bodyPr wrap="square">
+            <a:spAutoFit/>
+          </a:bodyPr>
+          <a:lstStyle/>
+          <a:p>
+            <a:pPr>
+              <a:spcAft>
+                <a:spcPts val="600"/>
+              </a:spcAft>
+            </a:pPr>
+            <a:r>
+              <a:rPr sz="2800" b="1">
+                <a:solidFill>
+                  <a:srgbClr val="0F172A"/>
+                </a:solidFill>
+              </a:rPr>
+              <a:t>Controlled soil sweep — analyzer interpretation</a:t>
+            </a:r>
+          </a:p>
+        </p:txBody>
+      </p:sp>
+      <p:sp>
+        <p:nvSpPr>
+          <p:cNvPr id="3" name="TextBox 2"/>
+          <p:cNvSpPr txBox="1"/>
+          <p:nvPr/>
+        </p:nvSpPr>
+        <p:spPr>
+          <a:xfrm>
+            <a:off x="457200" y="1188720"/>
+            <a:ext cx="11277295" cy="5303520"/>
+          </a:xfrm>
+          <a:prstGeom prst="rect">
+            <a:avLst/>
+          </a:prstGeom>
+          <a:noFill/>
+        </p:spPr>
+        <p:txBody>
+          <a:bodyPr wrap="square">
+            <a:spAutoFit/>
+          </a:bodyPr>
+          <a:lstStyle/>
+          <a:p>
+            <a:pPr>
+              <a:spcAft>
+                <a:spcPts val="600"/>
+              </a:spcAft>
+            </a:pPr>
+            <a:r>
+              <a:rPr b="1" sz="1400">
+                <a:solidFill>
+                  <a:srgbClr val="2C7FB8"/>
+                </a:solidFill>
+              </a:rPr>
+              <a:t>finding:  </a:t>
+            </a:r>
+            <a:r>
+              <a:rPr sz="1400">
+                <a:solidFill>
+                  <a:srgbClr val="0F172A"/>
+                </a:solidFill>
+              </a:rPr>
+              <a:t>soil control (forcing held at 1373 mm/yr, 7 columns): strongest predictor = recharge_vs_clay_max (r=-0.932)</a:t>
+            </a:r>
+          </a:p>
+        </p:txBody>
+      </p:sp>
+    </p:spTree>
+  </p:cSld>
+  <p:clrMapOvr>
+    <a:masterClrMapping/>
+  </p:clrMapOvr>
+</p:sld>
+</file>
+
+<file path=ppt/slides/slide22.xml><?xml version="1.0" encoding="utf-8"?>
 <p:sld xmlns:a="http://schemas.openxmlformats.org/drawingml/2006/main" xmlns:p="http://schemas.openxmlformats.org/presentationml/2006/main" xmlns:r="http://schemas.openxmlformats.org/officeDocument/2006/relationships">
   <p:cSld>
     <p:spTree>
@@ -5333,253 +5991,6 @@
 </p:sld>
 </file>
 
-<file path=ppt/slides/slide2.xml><?xml version="1.0" encoding="utf-8"?>
-<p:sld xmlns:a="http://schemas.openxmlformats.org/drawingml/2006/main" xmlns:p="http://schemas.openxmlformats.org/presentationml/2006/main" xmlns:r="http://schemas.openxmlformats.org/officeDocument/2006/relationships">
-  <p:cSld>
-    <p:spTree>
-      <p:nvGrpSpPr>
-        <p:cNvPr id="1" name=""/>
-        <p:cNvGrpSpPr/>
-        <p:nvPr/>
-      </p:nvGrpSpPr>
-      <p:grpSpPr/>
-      <p:sp>
-        <p:nvSpPr>
-          <p:cNvPr id="2" name="TextBox 1"/>
-          <p:cNvSpPr txBox="1"/>
-          <p:nvPr/>
-        </p:nvSpPr>
-        <p:spPr>
-          <a:xfrm>
-            <a:off x="457200" y="228600"/>
-            <a:ext cx="11277295" cy="640080"/>
-          </a:xfrm>
-          <a:prstGeom prst="rect">
-            <a:avLst/>
-          </a:prstGeom>
-          <a:noFill/>
-        </p:spPr>
-        <p:txBody>
-          <a:bodyPr wrap="square">
-            <a:spAutoFit/>
-          </a:bodyPr>
-          <a:lstStyle/>
-          <a:p>
-            <a:pPr>
-              <a:spcAft>
-                <a:spcPts val="600"/>
-              </a:spcAft>
-            </a:pPr>
-            <a:r>
-              <a:rPr sz="2800" b="1">
-                <a:solidFill>
-                  <a:srgbClr val="0F172A"/>
-                </a:solidFill>
-              </a:rPr>
-              <a:t>Case 1 — Naches</a:t>
-            </a:r>
-          </a:p>
-        </p:txBody>
-      </p:sp>
-      <p:sp>
-        <p:nvSpPr>
-          <p:cNvPr id="3" name="TextBox 2"/>
-          <p:cNvSpPr txBox="1"/>
-          <p:nvPr/>
-        </p:nvSpPr>
-        <p:spPr>
-          <a:xfrm>
-            <a:off x="457200" y="868680"/>
-            <a:ext cx="11277295" cy="365760"/>
-          </a:xfrm>
-          <a:prstGeom prst="rect">
-            <a:avLst/>
-          </a:prstGeom>
-          <a:noFill/>
-        </p:spPr>
-        <p:txBody>
-          <a:bodyPr wrap="square">
-            <a:spAutoFit/>
-          </a:bodyPr>
-          <a:lstStyle/>
-          <a:p>
-            <a:pPr>
-              <a:spcAft>
-                <a:spcPts val="600"/>
-              </a:spcAft>
-            </a:pPr>
-            <a:r>
-              <a:rPr sz="1300" b="0">
-                <a:solidFill>
-                  <a:srgbClr val="475569"/>
-                </a:solidFill>
-              </a:rPr>
-              <a:t>HUC 17030002 · 2860.6 km² · elevation 352.0–1977.4 m</a:t>
-            </a:r>
-          </a:p>
-        </p:txBody>
-      </p:sp>
-      <p:sp>
-        <p:nvSpPr>
-          <p:cNvPr id="4" name="TextBox 3"/>
-          <p:cNvSpPr txBox="1"/>
-          <p:nvPr/>
-        </p:nvSpPr>
-        <p:spPr>
-          <a:xfrm>
-            <a:off x="457200" y="1371600"/>
-            <a:ext cx="11277295" cy="1005840"/>
-          </a:xfrm>
-          <a:prstGeom prst="rect">
-            <a:avLst/>
-          </a:prstGeom>
-          <a:noFill/>
-        </p:spPr>
-        <p:txBody>
-          <a:bodyPr wrap="square">
-            <a:spAutoFit/>
-          </a:bodyPr>
-          <a:lstStyle/>
-          <a:p>
-            <a:pPr>
-              <a:spcAft>
-                <a:spcPts val="600"/>
-              </a:spcAft>
-            </a:pPr>
-            <a:r>
-              <a:rPr sz="1800" b="1">
-                <a:solidFill>
-                  <a:srgbClr val="2C7FB8"/>
-                </a:solidFill>
-              </a:rPr>
-              <a:t>“Determine the partitioning of runoff, infiltration, and recharge and the processes that control it across the Naches sub-watershed (HUC8 17030002, eastern Cascades, WA), and validate against observations”</a:t>
-            </a:r>
-          </a:p>
-        </p:txBody>
-      </p:sp>
-      <p:sp>
-        <p:nvSpPr>
-          <p:cNvPr id="5" name="TextBox 4"/>
-          <p:cNvSpPr txBox="1"/>
-          <p:nvPr/>
-        </p:nvSpPr>
-        <p:spPr>
-          <a:xfrm>
-            <a:off x="457200" y="2468880"/>
-            <a:ext cx="11277295" cy="3931920"/>
-          </a:xfrm>
-          <a:prstGeom prst="rect">
-            <a:avLst/>
-          </a:prstGeom>
-          <a:noFill/>
-        </p:spPr>
-        <p:txBody>
-          <a:bodyPr wrap="square">
-            <a:spAutoFit/>
-          </a:bodyPr>
-          <a:lstStyle/>
-          <a:p>
-            <a:pPr>
-              <a:spcAft>
-                <a:spcPts val="600"/>
-              </a:spcAft>
-            </a:pPr>
-            <a:r>
-              <a:rPr b="1" sz="1400">
-                <a:solidFill>
-                  <a:srgbClr val="2C7FB8"/>
-                </a:solidFill>
-              </a:rPr>
-              <a:t>goal:  </a:t>
-            </a:r>
-            <a:r>
-              <a:rPr sz="1400">
-                <a:solidFill>
-                  <a:srgbClr val="0F172A"/>
-                </a:solidFill>
-              </a:rPr>
-              <a:t>Mechanistic: quantify partitioning of precip+snowmelt into surface runoff, infiltration, and deep drainage (recharge) across the Naches, and attribute it to elevation/snow regime, soil layering, and ET</a:t>
-            </a:r>
-          </a:p>
-          <a:p>
-            <a:pPr>
-              <a:spcAft>
-                <a:spcPts val="600"/>
-              </a:spcAft>
-            </a:pPr>
-            <a:r>
-              <a:rPr b="1" sz="1400">
-                <a:solidFill>
-                  <a:srgbClr val="2C7FB8"/>
-                </a:solidFill>
-              </a:rPr>
-              <a:t>goal:  </a:t>
-            </a:r>
-            <a:r>
-              <a:rPr sz="1400">
-                <a:solidFill>
-                  <a:srgbClr val="0F172A"/>
-                </a:solidFill>
-              </a:rPr>
-              <a:t>Validation: confront simulated SWE against SNOTEL and integrated runoff against USGS streamflow; treat recharge as an unvalidated water-balance residual</a:t>
-            </a:r>
-          </a:p>
-          <a:p>
-            <a:pPr>
-              <a:spcAft>
-                <a:spcPts val="600"/>
-              </a:spcAft>
-            </a:pPr>
-            <a:r>
-              <a:rPr b="1" sz="1400">
-                <a:solidFill>
-                  <a:srgbClr val="2C7FB8"/>
-                </a:solidFill>
-              </a:rPr>
-              <a:t>sampling:  </a:t>
-            </a:r>
-            <a:r>
-              <a:rPr sz="1400">
-                <a:solidFill>
-                  <a:srgbClr val="0F172A"/>
-                </a:solidFill>
-              </a:rPr>
-              <a:t>N=10 — stratified (elevation primary, soil-layering secondary) with validation columns pinned to observation sites</a:t>
-            </a:r>
-          </a:p>
-          <a:p>
-            <a:pPr>
-              <a:spcAft>
-                <a:spcPts val="600"/>
-              </a:spcAft>
-            </a:pPr>
-            <a:r>
-              <a:rPr b="1" sz="1400">
-                <a:solidFill>
-                  <a:srgbClr val="2C7FB8"/>
-                </a:solidFill>
-              </a:rPr>
-              <a:t>why N:  </a:t>
-            </a:r>
-            <a:r>
-              <a:rPr sz="1400">
-                <a:solidFill>
-                  <a:srgbClr val="0F172A"/>
-                </a:solidFill>
-              </a:rPr>
-              <a:t>4 elevation bands x 2 soil contrasts = 8 to span the dominant snow-regime gradient and the infiltration-vs-recharge soil control, +2 replicates at the rain-snow transition (bands 2-3) where partitioning is most sensitive. Soil kept to 2 levels because only point SSURGO exists (gridded soil is a gap).</a:t>
-            </a:r>
-          </a:p>
-        </p:txBody>
-      </p:sp>
-    </p:spTree>
-  </p:cSld>
-  <p:clrMapOvr>
-    <a:masterClrMapping/>
-  </p:clrMapOvr>
-</p:sld>
-</file>
-
 <file path=ppt/slides/slide3.xml><?xml version="1.0" encoding="utf-8"?>
 <p:sld xmlns:a="http://schemas.openxmlformats.org/drawingml/2006/main" xmlns:p="http://schemas.openxmlformats.org/presentationml/2006/main" xmlns:r="http://schemas.openxmlformats.org/officeDocument/2006/relationships">
   <p:cSld>
@@ -6024,7 +6435,7 @@
                   <a:srgbClr val="0F172A"/>
                 </a:solidFill>
               </a:rPr>
-              <a:t>Case 2 — Naches</a:t>
+              <a:t>Naches — evaluation vs observations</a:t>
             </a:r>
           </a:p>
         </p:txBody>
@@ -6062,7 +6473,7 @@
                   <a:srgbClr val="475569"/>
                 </a:solidFill>
               </a:rPr>
-              <a:t>HUC 17030002 · 2860.6 km² · elevation 352.0–1977.4 m</a:t>
+              <a:t>what could be compared honestly, and what still blocks rigorous validation</a:t>
             </a:r>
           </a:p>
         </p:txBody>
@@ -6075,8 +6486,8 @@
         </p:nvSpPr>
         <p:spPr>
           <a:xfrm>
-            <a:off x="457200" y="1371600"/>
-            <a:ext cx="11277295" cy="1005840"/>
+            <a:off x="457200" y="1143000"/>
+            <a:ext cx="11277295" cy="2194560"/>
           </a:xfrm>
           <a:prstGeom prst="rect">
             <a:avLst/>
@@ -6095,200 +6506,117 @@
               </a:spcAft>
             </a:pPr>
             <a:r>
-              <a:rPr sz="1800" b="1">
+              <a:rPr b="1" sz="1300">
                 <a:solidFill>
                   <a:srgbClr val="2C7FB8"/>
                 </a:solidFill>
               </a:rPr>
-              <a:t>“Partitioning of runoff/recharge in the Naches sub-watershed (HUC8 17030002), validate with observations”</a:t>
-            </a:r>
-          </a:p>
-        </p:txBody>
-      </p:sp>
-      <p:sp>
-        <p:nvSpPr>
-          <p:cNvPr id="5" name="TextBox 4"/>
-          <p:cNvSpPr txBox="1"/>
+              <a:t>in-domain obs:  </a:t>
+            </a:r>
+            <a:r>
+              <a:rPr sz="1300">
+                <a:solidFill>
+                  <a:srgbClr val="0F172A"/>
+                </a:solidFill>
+              </a:rPr>
+              <a:t>SNOTEL 6 · stream gages 93 · GW wells 200 (5/6 sampled have records)</a:t>
+            </a:r>
+          </a:p>
+          <a:p>
+            <a:pPr>
+              <a:spcAft>
+                <a:spcPts val="600"/>
+              </a:spcAft>
+            </a:pPr>
+            <a:r>
+              <a:rPr b="1" sz="1300">
+                <a:solidFill>
+                  <a:srgbClr val="2C7FB8"/>
+                </a:solidFill>
+              </a:rPr>
+              <a:t>✓ COMPARED — water-table depth:  </a:t>
+            </a:r>
+            <a:r>
+              <a:rPr sz="1300">
+                <a:solidFill>
+                  <a:srgbClr val="0F172A"/>
+                </a:solidFill>
+              </a:rPr>
+              <a:t>model ZWT mean 8.48 m vs Fan 27.21 m (bias -18.73 m)</a:t>
+            </a:r>
+          </a:p>
+          <a:p>
+            <a:pPr>
+              <a:spcAft>
+                <a:spcPts val="600"/>
+              </a:spcAft>
+            </a:pPr>
+            <a:r>
+              <a:rPr b="1" sz="1300">
+                <a:solidFill>
+                  <a:srgbClr val="2C7FB8"/>
+                </a:solidFill>
+              </a:rPr>
+              <a:t>· context-only — integrated streamflow:  </a:t>
+            </a:r>
+            <a:r>
+              <a:rPr sz="1300">
+                <a:solidFill>
+                  <a:srgbClr val="0F172A"/>
+                </a:solidFill>
+              </a:rPr>
+              <a:t>modeled basin water yield (runoff+recharge) ≈ 490.1 mm/yr (reference; a single column produces no routed streamflow)  — needs: runoff routing / column aggregation</a:t>
+            </a:r>
+          </a:p>
+          <a:p>
+            <a:pPr>
+              <a:spcAft>
+                <a:spcPts val="600"/>
+              </a:spcAft>
+            </a:pPr>
+            <a:r>
+              <a:rPr b="1" sz="1300">
+                <a:solidFill>
+                  <a:srgbClr val="2C7FB8"/>
+                </a:solidFill>
+              </a:rPr>
+              <a:t>· context-only — snow water equivalent:  </a:t>
+            </a:r>
+            <a:r>
+              <a:rPr sz="1300">
+                <a:solidFill>
+                  <a:srgbClr val="0F172A"/>
+                </a:solidFill>
+              </a:rPr>
+              <a:t>SNOTEL stations present, but the run has no SWE output to compare  — needs: snow/SWE history output + elevation-downscaled forcing</a:t>
+            </a:r>
+          </a:p>
+        </p:txBody>
+      </p:sp>
+      <p:pic>
+        <p:nvPicPr>
+          <p:cNvPr id="5" name="Picture 4" descr="validation.png"/>
+          <p:cNvPicPr>
+            <a:picLocks noChangeAspect="1"/>
+          </p:cNvPicPr>
           <p:nvPr/>
-        </p:nvSpPr>
-        <p:spPr>
-          <a:xfrm>
-            <a:off x="457200" y="2468880"/>
-            <a:ext cx="11277295" cy="3931920"/>
+        </p:nvPicPr>
+        <p:blipFill>
+          <a:blip r:embed="rId2"/>
+          <a:stretch>
+            <a:fillRect/>
+          </a:stretch>
+        </p:blipFill>
+        <p:spPr>
+          <a:xfrm>
+            <a:off x="2235985" y="3520440"/>
+            <a:ext cx="7719724" cy="3200400"/>
           </a:xfrm>
           <a:prstGeom prst="rect">
             <a:avLst/>
           </a:prstGeom>
-          <a:noFill/>
-        </p:spPr>
-        <p:txBody>
-          <a:bodyPr wrap="square">
-            <a:spAutoFit/>
-          </a:bodyPr>
-          <a:lstStyle/>
-          <a:p>
-            <a:pPr>
-              <a:spcAft>
-                <a:spcPts val="600"/>
-              </a:spcAft>
-            </a:pPr>
-            <a:r>
-              <a:rPr b="1" sz="1400">
-                <a:solidFill>
-                  <a:srgbClr val="2C7FB8"/>
-                </a:solidFill>
-              </a:rPr>
-              <a:t>goal:  </a:t>
-            </a:r>
-            <a:r>
-              <a:rPr sz="1400">
-                <a:solidFill>
-                  <a:srgbClr val="0F172A"/>
-                </a:solidFill>
-              </a:rPr>
-              <a:t>Mechanistic: quantify how the representative Naches profile partitions incoming water among ET, surface runoff (QOVER) and sub-surface drainage/recharge (QDRAI), and how that partitioning shifts with water availability (forcing period)</a:t>
-            </a:r>
-          </a:p>
-          <a:p>
-            <a:pPr>
-              <a:spcAft>
-                <a:spcPts val="600"/>
-              </a:spcAft>
-            </a:pPr>
-            <a:r>
-              <a:rPr b="1" sz="1400">
-                <a:solidFill>
-                  <a:srgbClr val="2C7FB8"/>
-                </a:solidFill>
-              </a:rPr>
-              <a:t>goal:  </a:t>
-            </a:r>
-            <a:r>
-              <a:rPr sz="1400">
-                <a:solidFill>
-                  <a:srgbClr val="0F172A"/>
-                </a:solidFill>
-              </a:rPr>
-              <a:t>Validation: compare ELM water balance against integrated streamflow at in-HUC USGS gages, SNOTEL SWE as snow driver, and Fan-2013 WTD as deep-storage context — MOST of which is blocked by current execution limits</a:t>
-            </a:r>
-          </a:p>
-          <a:p>
-            <a:pPr>
-              <a:spcAft>
-                <a:spcPts val="600"/>
-              </a:spcAft>
-            </a:pPr>
-            <a:r>
-              <a:rPr b="1" sz="1400">
-                <a:solidFill>
-                  <a:srgbClr val="2C7FB8"/>
-                </a:solidFill>
-              </a:rPr>
-              <a:t>sampling:  </a:t>
-            </a:r>
-            <a:r>
-              <a:rPr sz="1400">
-                <a:solidFill>
-                  <a:srgbClr val="0F172A"/>
-                </a:solidFill>
-              </a:rPr>
-              <a:t>N=8 — stratified (elevation bands for surface-data sampling) + forcing-period treatment on a representative column</a:t>
-            </a:r>
-          </a:p>
-          <a:p>
-            <a:pPr>
-              <a:spcAft>
-                <a:spcPts val="600"/>
-              </a:spcAft>
-            </a:pPr>
-            <a:r>
-              <a:rPr b="1" sz="1400">
-                <a:solidFill>
-                  <a:srgbClr val="2C7FB8"/>
-                </a:solidFill>
-              </a:rPr>
-              <a:t>why N:  </a:t>
-            </a:r>
-            <a:r>
-              <a:rPr sz="1400">
-                <a:solidFill>
-                  <a:srgbClr val="0F172A"/>
-                </a:solidFill>
-              </a:rPr>
-              <a:t>4 columns to span the four elevation bands and sample whatever per-column surface-data (PFT/default soil) heterogeneity exists across the basin under baseline forcing (NOT an elevation/climate test — forcing is uniform). Plus a forcing-period sweep (wet + drought = 2 extra periods) applied to two representative columns (1 mid-elevation valley-influenced, 1 upland) = 4 more, to isolate the only usable mechanistic lever: water-availability control on partitioning. Total 8. A denser grid is unjustified because neither elevation-climate nor soil texture can be resolved.</a:t>
-            </a:r>
-          </a:p>
-          <a:p>
-            <a:pPr>
-              <a:spcAft>
-                <a:spcPts val="600"/>
-              </a:spcAft>
-            </a:pPr>
-            <a:r>
-              <a:rPr b="1" sz="1400">
-                <a:solidFill>
-                  <a:srgbClr val="2C7FB8"/>
-                </a:solidFill>
-              </a:rPr>
-              <a:t>feasibility:  </a:t>
-            </a:r>
-            <a:r>
-              <a:rPr sz="1400">
-                <a:solidFill>
-                  <a:srgbClr val="0F172A"/>
-                </a:solidFill>
-              </a:rPr>
-              <a:t>partial — the elevation/snow-driven partitioning mechanism (the brief's stated primary control) is NOT representable, and the observation-based validation goal is largely blocked. Only the soil-profile water-balance partitioning and its forcing-period sensitivity are answerable.</a:t>
-            </a:r>
-          </a:p>
-          <a:p>
-            <a:pPr>
-              <a:spcAft>
-                <a:spcPts val="600"/>
-              </a:spcAft>
-            </a:pPr>
-            <a:r>
-              <a:rPr b="1" sz="1400">
-                <a:solidFill>
-                  <a:srgbClr val="2C7FB8"/>
-                </a:solidFill>
-              </a:rPr>
-              <a:t>not answerable:  </a:t>
-            </a:r>
-            <a:r>
-              <a:rPr sz="1400">
-                <a:solidFill>
-                  <a:srgbClr val="0F172A"/>
-                </a:solidFill>
-              </a:rPr>
-              <a:t>Elevation / snow-regime control on partitioning (the brief's stated primary driver) — needs elevation-downscaled forcing</a:t>
-            </a:r>
-          </a:p>
-          <a:p>
-            <a:pPr>
-              <a:spcAft>
-                <a:spcPts val="600"/>
-              </a:spcAft>
-            </a:pPr>
-            <a:r>
-              <a:rPr b="1" sz="1400">
-                <a:solidFill>
-                  <a:srgbClr val="2C7FB8"/>
-                </a:solidFill>
-              </a:rPr>
-              <a:t>not answerable:  </a:t>
-            </a:r>
-            <a:r>
-              <a:rPr sz="1400">
-                <a:solidFill>
-                  <a:srgbClr val="0F172A"/>
-                </a:solidFill>
-              </a:rPr>
-              <a:t>Validation against SNOTEL SWE / melt timing — needs snow/SWE history output AND elevation-downscaled forcing</a:t>
-            </a:r>
-          </a:p>
-        </p:txBody>
-      </p:sp>
+        </p:spPr>
+      </p:pic>
     </p:spTree>
   </p:cSld>
   <p:clrMapOvr>
@@ -6340,35 +6668,271 @@
                   <a:srgbClr val="0F172A"/>
                 </a:solidFill>
               </a:rPr>
-              <a:t>Naches — sampling design (Tier-2 expander)</a:t>
-            </a:r>
-          </a:p>
-        </p:txBody>
-      </p:sp>
-      <p:pic>
-        <p:nvPicPr>
-          <p:cNvPr id="3" name="Picture 2" descr="sampling_design.png"/>
-          <p:cNvPicPr>
-            <a:picLocks noChangeAspect="1"/>
-          </p:cNvPicPr>
+              <a:t>Case 2 — Naches</a:t>
+            </a:r>
+          </a:p>
+        </p:txBody>
+      </p:sp>
+      <p:sp>
+        <p:nvSpPr>
+          <p:cNvPr id="3" name="TextBox 2"/>
+          <p:cNvSpPr txBox="1"/>
           <p:nvPr/>
-        </p:nvPicPr>
-        <p:blipFill>
-          <a:blip r:embed="rId2"/>
-          <a:stretch>
-            <a:fillRect/>
-          </a:stretch>
-        </p:blipFill>
-        <p:spPr>
-          <a:xfrm>
-            <a:off x="2067408" y="1051560"/>
-            <a:ext cx="8056879" cy="5577840"/>
+        </p:nvSpPr>
+        <p:spPr>
+          <a:xfrm>
+            <a:off x="457200" y="868680"/>
+            <a:ext cx="11277295" cy="365760"/>
           </a:xfrm>
           <a:prstGeom prst="rect">
             <a:avLst/>
           </a:prstGeom>
-        </p:spPr>
-      </p:pic>
+          <a:noFill/>
+        </p:spPr>
+        <p:txBody>
+          <a:bodyPr wrap="square">
+            <a:spAutoFit/>
+          </a:bodyPr>
+          <a:lstStyle/>
+          <a:p>
+            <a:pPr>
+              <a:spcAft>
+                <a:spcPts val="600"/>
+              </a:spcAft>
+            </a:pPr>
+            <a:r>
+              <a:rPr sz="1300" b="0">
+                <a:solidFill>
+                  <a:srgbClr val="475569"/>
+                </a:solidFill>
+              </a:rPr>
+              <a:t>HUC 17030002 · 2860.6 km² · elevation 352.0–1977.4 m</a:t>
+            </a:r>
+          </a:p>
+        </p:txBody>
+      </p:sp>
+      <p:sp>
+        <p:nvSpPr>
+          <p:cNvPr id="4" name="TextBox 3"/>
+          <p:cNvSpPr txBox="1"/>
+          <p:nvPr/>
+        </p:nvSpPr>
+        <p:spPr>
+          <a:xfrm>
+            <a:off x="457200" y="1371600"/>
+            <a:ext cx="11277295" cy="1005840"/>
+          </a:xfrm>
+          <a:prstGeom prst="rect">
+            <a:avLst/>
+          </a:prstGeom>
+          <a:noFill/>
+        </p:spPr>
+        <p:txBody>
+          <a:bodyPr wrap="square">
+            <a:spAutoFit/>
+          </a:bodyPr>
+          <a:lstStyle/>
+          <a:p>
+            <a:pPr>
+              <a:spcAft>
+                <a:spcPts val="600"/>
+              </a:spcAft>
+            </a:pPr>
+            <a:r>
+              <a:rPr sz="1800" b="1">
+                <a:solidFill>
+                  <a:srgbClr val="2C7FB8"/>
+                </a:solidFill>
+              </a:rPr>
+              <a:t>“Partitioning of runoff/recharge in the Naches sub-watershed (HUC8 17030002), validate with observations”</a:t>
+            </a:r>
+          </a:p>
+        </p:txBody>
+      </p:sp>
+      <p:sp>
+        <p:nvSpPr>
+          <p:cNvPr id="5" name="TextBox 4"/>
+          <p:cNvSpPr txBox="1"/>
+          <p:nvPr/>
+        </p:nvSpPr>
+        <p:spPr>
+          <a:xfrm>
+            <a:off x="457200" y="2468880"/>
+            <a:ext cx="11277295" cy="3931920"/>
+          </a:xfrm>
+          <a:prstGeom prst="rect">
+            <a:avLst/>
+          </a:prstGeom>
+          <a:noFill/>
+        </p:spPr>
+        <p:txBody>
+          <a:bodyPr wrap="square">
+            <a:spAutoFit/>
+          </a:bodyPr>
+          <a:lstStyle/>
+          <a:p>
+            <a:pPr>
+              <a:spcAft>
+                <a:spcPts val="600"/>
+              </a:spcAft>
+            </a:pPr>
+            <a:r>
+              <a:rPr b="1" sz="1400">
+                <a:solidFill>
+                  <a:srgbClr val="2C7FB8"/>
+                </a:solidFill>
+              </a:rPr>
+              <a:t>goal:  </a:t>
+            </a:r>
+            <a:r>
+              <a:rPr sz="1400">
+                <a:solidFill>
+                  <a:srgbClr val="0F172A"/>
+                </a:solidFill>
+              </a:rPr>
+              <a:t>Mechanistic: quantify how the representative Naches profile partitions incoming water among ET, surface runoff (QOVER) and sub-surface drainage/recharge (QDRAI), and how that partitioning shifts with water availability (forcing period)</a:t>
+            </a:r>
+          </a:p>
+          <a:p>
+            <a:pPr>
+              <a:spcAft>
+                <a:spcPts val="600"/>
+              </a:spcAft>
+            </a:pPr>
+            <a:r>
+              <a:rPr b="1" sz="1400">
+                <a:solidFill>
+                  <a:srgbClr val="2C7FB8"/>
+                </a:solidFill>
+              </a:rPr>
+              <a:t>goal:  </a:t>
+            </a:r>
+            <a:r>
+              <a:rPr sz="1400">
+                <a:solidFill>
+                  <a:srgbClr val="0F172A"/>
+                </a:solidFill>
+              </a:rPr>
+              <a:t>Validation: compare ELM water balance against integrated streamflow at in-HUC USGS gages, SNOTEL SWE as snow driver, and Fan-2013 WTD as deep-storage context — MOST of which is blocked by current execution limits</a:t>
+            </a:r>
+          </a:p>
+          <a:p>
+            <a:pPr>
+              <a:spcAft>
+                <a:spcPts val="600"/>
+              </a:spcAft>
+            </a:pPr>
+            <a:r>
+              <a:rPr b="1" sz="1400">
+                <a:solidFill>
+                  <a:srgbClr val="2C7FB8"/>
+                </a:solidFill>
+              </a:rPr>
+              <a:t>sampling:  </a:t>
+            </a:r>
+            <a:r>
+              <a:rPr sz="1400">
+                <a:solidFill>
+                  <a:srgbClr val="0F172A"/>
+                </a:solidFill>
+              </a:rPr>
+              <a:t>N=8 — stratified (elevation bands for surface-data sampling) + forcing-period treatment on a representative column</a:t>
+            </a:r>
+          </a:p>
+          <a:p>
+            <a:pPr>
+              <a:spcAft>
+                <a:spcPts val="600"/>
+              </a:spcAft>
+            </a:pPr>
+            <a:r>
+              <a:rPr b="1" sz="1400">
+                <a:solidFill>
+                  <a:srgbClr val="2C7FB8"/>
+                </a:solidFill>
+              </a:rPr>
+              <a:t>why N:  </a:t>
+            </a:r>
+            <a:r>
+              <a:rPr sz="1400">
+                <a:solidFill>
+                  <a:srgbClr val="0F172A"/>
+                </a:solidFill>
+              </a:rPr>
+              <a:t>4 columns to span the four elevation bands and sample whatever per-column surface-data (PFT/default soil) heterogeneity exists across the basin under baseline forcing (NOT an elevation/climate test — forcing is uniform). Plus a forcing-period sweep (wet + drought = 2 extra periods) applied to two representative columns (1 mid-elevation valley-influenced, 1 upland) = 4 more, to isolate the only usable mechanistic lever: water-availability control on partitioning. Total 8. A denser grid is unjustified because neither elevation-climate nor soil texture can be resolved.</a:t>
+            </a:r>
+          </a:p>
+          <a:p>
+            <a:pPr>
+              <a:spcAft>
+                <a:spcPts val="600"/>
+              </a:spcAft>
+            </a:pPr>
+            <a:r>
+              <a:rPr b="1" sz="1400">
+                <a:solidFill>
+                  <a:srgbClr val="2C7FB8"/>
+                </a:solidFill>
+              </a:rPr>
+              <a:t>feasibility:  </a:t>
+            </a:r>
+            <a:r>
+              <a:rPr sz="1400">
+                <a:solidFill>
+                  <a:srgbClr val="0F172A"/>
+                </a:solidFill>
+              </a:rPr>
+              <a:t>partial — the elevation/snow-driven partitioning mechanism (the brief's stated primary control) is NOT representable, and the observation-based validation goal is largely blocked. Only the soil-profile water-balance partitioning and its forcing-period sensitivity are answerable.</a:t>
+            </a:r>
+          </a:p>
+          <a:p>
+            <a:pPr>
+              <a:spcAft>
+                <a:spcPts val="600"/>
+              </a:spcAft>
+            </a:pPr>
+            <a:r>
+              <a:rPr b="1" sz="1400">
+                <a:solidFill>
+                  <a:srgbClr val="2C7FB8"/>
+                </a:solidFill>
+              </a:rPr>
+              <a:t>not answerable:  </a:t>
+            </a:r>
+            <a:r>
+              <a:rPr sz="1400">
+                <a:solidFill>
+                  <a:srgbClr val="0F172A"/>
+                </a:solidFill>
+              </a:rPr>
+              <a:t>Elevation / snow-regime control on partitioning (the brief's stated primary driver) — needs elevation-downscaled forcing</a:t>
+            </a:r>
+          </a:p>
+          <a:p>
+            <a:pPr>
+              <a:spcAft>
+                <a:spcPts val="600"/>
+              </a:spcAft>
+            </a:pPr>
+            <a:r>
+              <a:rPr b="1" sz="1400">
+                <a:solidFill>
+                  <a:srgbClr val="2C7FB8"/>
+                </a:solidFill>
+              </a:rPr>
+              <a:t>not answerable:  </a:t>
+            </a:r>
+            <a:r>
+              <a:rPr sz="1400">
+                <a:solidFill>
+                  <a:srgbClr val="0F172A"/>
+                </a:solidFill>
+              </a:rPr>
+              <a:t>Validation against SNOTEL SWE / melt timing — needs snow/SWE history output AND elevation-downscaled forcing</a:t>
+            </a:r>
+          </a:p>
+        </p:txBody>
+      </p:sp>
     </p:spTree>
   </p:cSld>
   <p:clrMapOvr>
@@ -6420,60 +6984,14 @@
                   <a:srgbClr val="0F172A"/>
                 </a:solidFill>
               </a:rPr>
-              <a:t>Naches — execution &amp; results</a:t>
-            </a:r>
-          </a:p>
-        </p:txBody>
-      </p:sp>
-      <p:sp>
-        <p:nvSpPr>
-          <p:cNvPr id="3" name="TextBox 2"/>
-          <p:cNvSpPr txBox="1"/>
-          <p:nvPr/>
-        </p:nvSpPr>
-        <p:spPr>
-          <a:xfrm>
-            <a:off x="457200" y="1005840"/>
-            <a:ext cx="11277295" cy="457200"/>
-          </a:xfrm>
-          <a:prstGeom prst="rect">
-            <a:avLst/>
-          </a:prstGeom>
-          <a:noFill/>
-        </p:spPr>
-        <p:txBody>
-          <a:bodyPr wrap="square">
-            <a:spAutoFit/>
-          </a:bodyPr>
-          <a:lstStyle/>
-          <a:p>
-            <a:pPr>
-              <a:spcAft>
-                <a:spcPts val="600"/>
-              </a:spcAft>
-            </a:pPr>
-            <a:r>
-              <a:rPr b="1" sz="1400">
-                <a:solidFill>
-                  <a:srgbClr val="2C7FB8"/>
-                </a:solidFill>
-              </a:rPr>
-              <a:t>execution:  </a:t>
-            </a:r>
-            <a:r>
-              <a:rPr sz="1400">
-                <a:solidFill>
-                  <a:srgbClr val="0F172A"/>
-                </a:solidFill>
-              </a:rPr>
-              <a:t>8/8 columns succeeded · ~3 min each (~15 s clone per column, shared executable)</a:t>
+              <a:t>Naches — sampling design (Tier-2 expander)</a:t>
             </a:r>
           </a:p>
         </p:txBody>
       </p:sp>
       <p:pic>
         <p:nvPicPr>
-          <p:cNvPr id="4" name="Picture 3" descr="elevation_gradient.png"/>
+          <p:cNvPr id="3" name="Picture 2" descr="sampling_design.png"/>
           <p:cNvPicPr>
             <a:picLocks noChangeAspect="1"/>
           </p:cNvPicPr>
@@ -6487,32 +7005,8 @@
         </p:blipFill>
         <p:spPr>
           <a:xfrm>
-            <a:off x="2220551" y="1600200"/>
-            <a:ext cx="7750593" cy="2514600"/>
-          </a:xfrm>
-          <a:prstGeom prst="rect">
-            <a:avLst/>
-          </a:prstGeom>
-        </p:spPr>
-      </p:pic>
-      <p:pic>
-        <p:nvPicPr>
-          <p:cNvPr id="5" name="Picture 4" descr="soil_control.png"/>
-          <p:cNvPicPr>
-            <a:picLocks noChangeAspect="1"/>
-          </p:cNvPicPr>
-          <p:nvPr/>
-        </p:nvPicPr>
-        <p:blipFill>
-          <a:blip r:embed="rId3"/>
-          <a:stretch>
-            <a:fillRect/>
-          </a:stretch>
-        </p:blipFill>
-        <p:spPr>
-          <a:xfrm>
-            <a:off x="3390104" y="4251960"/>
-            <a:ext cx="5411487" cy="2514600"/>
+            <a:off x="2067408" y="1051560"/>
+            <a:ext cx="8056879" cy="5577840"/>
           </a:xfrm>
           <a:prstGeom prst="rect">
             <a:avLst/>
@@ -6570,14 +7064,60 @@
                   <a:srgbClr val="0F172A"/>
                 </a:solidFill>
               </a:rPr>
-              <a:t>Naches — results (continued)</a:t>
+              <a:t>Naches — execution &amp; results</a:t>
+            </a:r>
+          </a:p>
+        </p:txBody>
+      </p:sp>
+      <p:sp>
+        <p:nvSpPr>
+          <p:cNvPr id="3" name="TextBox 2"/>
+          <p:cNvSpPr txBox="1"/>
+          <p:nvPr/>
+        </p:nvSpPr>
+        <p:spPr>
+          <a:xfrm>
+            <a:off x="457200" y="1005840"/>
+            <a:ext cx="11277295" cy="457200"/>
+          </a:xfrm>
+          <a:prstGeom prst="rect">
+            <a:avLst/>
+          </a:prstGeom>
+          <a:noFill/>
+        </p:spPr>
+        <p:txBody>
+          <a:bodyPr wrap="square">
+            <a:spAutoFit/>
+          </a:bodyPr>
+          <a:lstStyle/>
+          <a:p>
+            <a:pPr>
+              <a:spcAft>
+                <a:spcPts val="600"/>
+              </a:spcAft>
+            </a:pPr>
+            <a:r>
+              <a:rPr b="1" sz="1400">
+                <a:solidFill>
+                  <a:srgbClr val="2C7FB8"/>
+                </a:solidFill>
+              </a:rPr>
+              <a:t>execution:  </a:t>
+            </a:r>
+            <a:r>
+              <a:rPr sz="1400">
+                <a:solidFill>
+                  <a:srgbClr val="0F172A"/>
+                </a:solidFill>
+              </a:rPr>
+              <a:t>8/8 columns succeeded · ~3 min each (~15 s clone per column, shared executable)</a:t>
             </a:r>
           </a:p>
         </p:txBody>
       </p:sp>
       <p:pic>
         <p:nvPicPr>
-          <p:cNvPr id="3" name="Picture 2" descr="debug_timeseries.png"/>
+          <p:cNvPr id="4" name="Picture 3" descr="elevation_gradient.png"/>
           <p:cNvPicPr>
             <a:picLocks noChangeAspect="1"/>
           </p:cNvPicPr>
@@ -6591,8 +7131,32 @@
         </p:blipFill>
         <p:spPr>
           <a:xfrm>
-            <a:off x="472287" y="1188720"/>
-            <a:ext cx="11247120" cy="4183902"/>
+            <a:off x="2220551" y="1600200"/>
+            <a:ext cx="7750593" cy="2514600"/>
+          </a:xfrm>
+          <a:prstGeom prst="rect">
+            <a:avLst/>
+          </a:prstGeom>
+        </p:spPr>
+      </p:pic>
+      <p:pic>
+        <p:nvPicPr>
+          <p:cNvPr id="5" name="Picture 4" descr="soil_control.png"/>
+          <p:cNvPicPr>
+            <a:picLocks noChangeAspect="1"/>
+          </p:cNvPicPr>
+          <p:nvPr/>
+        </p:nvPicPr>
+        <p:blipFill>
+          <a:blip r:embed="rId3"/>
+          <a:stretch>
+            <a:fillRect/>
+          </a:stretch>
+        </p:blipFill>
+        <p:spPr>
+          <a:xfrm>
+            <a:off x="3390104" y="4251960"/>
+            <a:ext cx="5411487" cy="2514600"/>
           </a:xfrm>
           <a:prstGeom prst="rect">
             <a:avLst/>

</xml_diff>

<commit_message>
docs: regenerate story deck with NSE/KGE hydrograph validation
Co-Authored-By: Claude Opus 4.8 <noreply@anthropic.com>
</commit_message>
<xml_diff>
--- a/docs/slides/story_20260702.pptx
+++ b/docs/slides/story_20260702.pptx
@@ -3662,6 +3662,29 @@
                   <a:srgbClr val="2C7FB8"/>
                 </a:solidFill>
               </a:rPr>
+              <a:t>✓ COMPARED — streamflow (daily hydrograph):  </a:t>
+            </a:r>
+            <a:r>
+              <a:rPr sz="1300">
+                <a:solidFill>
+                  <a:srgbClr val="0F172A"/>
+                </a:solidFill>
+              </a:rPr>
+              <a:t>NSE=-1.127, KGE=-0.567 (r=0.052, variability α=0.182, bias β=0.057) — column-mean QOVER+QDRAI vs gauge</a:t>
+            </a:r>
+          </a:p>
+          <a:p>
+            <a:pPr>
+              <a:spcAft>
+                <a:spcPts val="600"/>
+              </a:spcAft>
+            </a:pPr>
+            <a:r>
+              <a:rPr b="1" sz="1300">
+                <a:solidFill>
+                  <a:srgbClr val="2C7FB8"/>
+                </a:solidFill>
+              </a:rPr>
               <a:t>· context-only — snow water equivalent:  </a:t>
             </a:r>
             <a:r>
@@ -3670,7 +3693,7 @@
                   <a:srgbClr val="0F172A"/>
                 </a:solidFill>
               </a:rPr>
-              <a:t>observed peak SWE 645–1981 mm across stations vs column forcing precip 793, 1373 mm/yr — the run has no SWE output to compare  — needs: snow/SWE history output + elevation-downscaled forcing</a:t>
+              <a:t>observed peak SWE 645–1981 mm across stations vs column forcing precip 793, 1373 mm/yr — this run predates SWE (H2OSNO) in the history output  — needs: snow/SWE history output (default since 2026-07) + elevation-downscaled forcing</a:t>
             </a:r>
           </a:p>
         </p:txBody>
@@ -3691,8 +3714,8 @@
         </p:blipFill>
         <p:spPr>
           <a:xfrm>
-            <a:off x="1386413" y="3520440"/>
-            <a:ext cx="9418869" cy="3200400"/>
+            <a:off x="4031750" y="3520440"/>
+            <a:ext cx="4128195" cy="3200400"/>
           </a:xfrm>
           <a:prstGeom prst="rect">
             <a:avLst/>
@@ -4669,6 +4692,29 @@
                   <a:srgbClr val="2C7FB8"/>
                 </a:solidFill>
               </a:rPr>
+              <a:t>✓ COMPARED — streamflow (daily hydrograph):  </a:t>
+            </a:r>
+            <a:r>
+              <a:rPr sz="1300">
+                <a:solidFill>
+                  <a:srgbClr val="0F172A"/>
+                </a:solidFill>
+              </a:rPr>
+              <a:t>NSE=-1.462, KGE=-0.151 (r=0.235, variability α=0.702, bias β=0.193) — column-mean QOVER+QDRAI vs gauge</a:t>
+            </a:r>
+          </a:p>
+          <a:p>
+            <a:pPr>
+              <a:spcAft>
+                <a:spcPts val="600"/>
+              </a:spcAft>
+            </a:pPr>
+            <a:r>
+              <a:rPr b="1" sz="1300">
+                <a:solidFill>
+                  <a:srgbClr val="2C7FB8"/>
+                </a:solidFill>
+              </a:rPr>
               <a:t>· context-only — snow water equivalent:  </a:t>
             </a:r>
             <a:r>
@@ -4677,7 +4723,7 @@
                   <a:srgbClr val="0F172A"/>
                 </a:solidFill>
               </a:rPr>
-              <a:t>observed peak SWE 843–843 mm across stations vs column forcing precip 530 mm/yr — the run has no SWE output to compare  — needs: snow/SWE history output + elevation-downscaled forcing</a:t>
+              <a:t>observed peak SWE 843–843 mm across stations vs column forcing precip 530 mm/yr — this run predates SWE (H2OSNO) in the history output  — needs: snow/SWE history output (default since 2026-07) + elevation-downscaled forcing</a:t>
             </a:r>
           </a:p>
         </p:txBody>
@@ -4698,8 +4744,8 @@
         </p:blipFill>
         <p:spPr>
           <a:xfrm>
-            <a:off x="1386413" y="3520440"/>
-            <a:ext cx="9418869" cy="3200400"/>
+            <a:off x="3981207" y="3520440"/>
+            <a:ext cx="4229280" cy="3200400"/>
           </a:xfrm>
           <a:prstGeom prst="rect">
             <a:avLst/>
@@ -6580,6 +6626,29 @@
                   <a:srgbClr val="2C7FB8"/>
                 </a:solidFill>
               </a:rPr>
+              <a:t>· context-only — streamflow (daily hydrograph):  </a:t>
+            </a:r>
+            <a:r>
+              <a:rPr sz="1300">
+                <a:solidFill>
+                  <a:srgbClr val="0F172A"/>
+                </a:solidFill>
+              </a:rPr>
+              <a:t>daily comparison unavailable</a:t>
+            </a:r>
+          </a:p>
+          <a:p>
+            <a:pPr>
+              <a:spcAft>
+                <a:spcPts val="600"/>
+              </a:spcAft>
+            </a:pPr>
+            <a:r>
+              <a:rPr b="1" sz="1300">
+                <a:solidFill>
+                  <a:srgbClr val="2C7FB8"/>
+                </a:solidFill>
+              </a:rPr>
               <a:t>· context-only — snow water equivalent:  </a:t>
             </a:r>
             <a:r>
@@ -6588,7 +6657,7 @@
                   <a:srgbClr val="0F172A"/>
                 </a:solidFill>
               </a:rPr>
-              <a:t>observed peak SWE 645–1981 mm across stations vs column forcing precip 793, 1373 mm/yr — the run has no SWE output to compare  — needs: snow/SWE history output + elevation-downscaled forcing</a:t>
+              <a:t>observed peak SWE 645–1981 mm across stations vs column forcing precip 793, 1373 mm/yr — this run predates SWE (H2OSNO) in the history output  — needs: snow/SWE history output (default since 2026-07) + elevation-downscaled forcing</a:t>
             </a:r>
           </a:p>
         </p:txBody>

</xml_diff>